<commit_message>
University logo on the talk; the author's speed-up run (1.81x)
Talk decks (EN, SQ): the University of Prishtina seal, in its own
colours on a white disc, on the title and closing slides. The Albanian
deck keeps English number formatting (21,519; 0.63%). The backup slide
quotes the measured 1.81x, 1.7x on the sparse family to 1.9x on the dense.

harness/speed.log now holds the author's measurement on all ten instances:
geometric mean 1.81x (sparse 1.70x, medium 1.88x, dense 1.89x). The file
previously held only the header line. The independent re-run from the
previous commit moves to harness/speed_cloud.log (1.76x) as a cross-check.
README Part 9.2 quotes 1.81x and points to both logs.

Co-Authored-By: Claude Opus 5.5 <noreply@anthropic.com>
Claude-Session: https://claude.ai/code/session_015zTx2mdJhEivSpaUsTWMRP
</commit_message>
<xml_diff>
--- a/SpOC3-Dekompozime-Torso-AlbShkenca2026-SQ.pptx
+++ b/SpOC3-Dekompozime-Torso-AlbShkenca2026-SQ.pptx
@@ -127,7 +127,7 @@
   <p:extLst>
     <p:ext uri="{521415D9-36F7-43E2-AB2F-B90AF26B5E84}">
       <p14:sectionLst xmlns:p14="http://schemas.microsoft.com/office/powerpoint/2010/main">
-        <p14:section name="Kumtesa" id="{ac2b8cbd-e406-8768-e982-e0af831f9b05}">
+        <p14:section name="Kumtesa" id="{1029733d-8089-38b1-7154-46a661a39ddc}">
           <p14:sldIdLst>
             <p14:sldId id="256"/>
             <p14:sldId id="257"/>
@@ -146,7 +146,7 @@
             <p14:sldId id="270"/>
           </p14:sldIdLst>
         </p14:section>
-        <p14:section name="Shtojcë" id="{5f0e003f-e096-7503-cc6c-837ce33b97c3}">
+        <p14:section name="Shtojcë" id="{12897e26-91c0-d4ae-9b9f-1a215a7c38dd}">
           <p14:sldIdLst>
             <p14:sldId id="271"/>
             <p14:sldId id="272"/>
@@ -1616,7 +1616,7 @@
           <a:p>
             <a:r>
               <a:rPr lang="en-US" dirty="0"/>
-              <a:t>Shtojcë, për pyetje rreth operatorëve të kërkimit. Burimet: harness/delta_check.log për saktësinë, harness/speed.log për përshpejtimin (rimatur më 14 tetor: mesatare gjeometrike 1.76×; një ekzekutim i mëparshëm me 1.81× nuk i ruajti rreshtat, prandaj thuaj 1.8×).</a:t>
+              <a:t>Shtojcë, për pyetje rreth operatorëve të kërkimit. Burimet: harness/delta_check.log për saktësinë, harness/speed.log për përshpejtimin (matja e autorit: 1.70× të rrallat, 1.88× të mesmet, 1.89× të dendurat; një rimatje e pavarur në një makinë tjetër dha 1.76×).</a:t>
             </a:r>
             <a:endParaRPr lang="en-US" dirty="0"/>
           </a:p>
@@ -3018,9 +3018,33 @@
           <a:chExt cx="0" cy="0"/>
         </a:xfrm>
       </p:grpSpPr>
-      <p:sp>
-        <p:nvSpPr>
-          <p:cNvPr id="2" name="Text 0"/>
+      <p:pic>
+        <p:nvPicPr>
+          <p:cNvPr id="2" name="Image 0" descr="Universiteti i Prishtinës">    </p:cNvPr>
+          <p:cNvPicPr>
+            <a:picLocks noChangeAspect="1"/>
+          </p:cNvPicPr>
+          <p:nvPr/>
+        </p:nvPicPr>
+        <p:blipFill>
+          <a:blip r:embed="rId1"/>
+          <a:stretch>
+            <a:fillRect/>
+          </a:stretch>
+        </p:blipFill>
+        <p:spPr>
+          <a:xfrm>
+            <a:off x="640080" y="566928"/>
+            <a:ext cx="914400" cy="914400"/>
+          </a:xfrm>
+          <a:prstGeom prst="rect">
+            <a:avLst/>
+          </a:prstGeom>
+        </p:spPr>
+      </p:pic>
+      <p:sp>
+        <p:nvSpPr>
+          <p:cNvPr id="3" name="Text 0"/>
           <p:cNvSpPr txBox="1"/>
           <p:nvPr/>
         </p:nvSpPr>
@@ -3059,7 +3083,7 @@
       </p:sp>
       <p:sp>
         <p:nvSpPr>
-          <p:cNvPr id="3" name="Text 1"/>
+          <p:cNvPr id="4" name="Text 1"/>
           <p:cNvSpPr txBox="1"/>
           <p:nvPr/>
         </p:nvSpPr>
@@ -3141,7 +3165,7 @@
       </p:sp>
       <p:sp>
         <p:nvSpPr>
-          <p:cNvPr id="4" name="Text 2"/>
+          <p:cNvPr id="5" name="Text 2"/>
           <p:cNvSpPr txBox="1"/>
           <p:nvPr/>
         </p:nvSpPr>
@@ -3180,7 +3204,7 @@
       </p:sp>
       <p:sp>
         <p:nvSpPr>
-          <p:cNvPr id="5" name="Text 3"/>
+          <p:cNvPr id="6" name="Text 3"/>
           <p:cNvSpPr txBox="1"/>
           <p:nvPr/>
         </p:nvSpPr>
@@ -3219,7 +3243,7 @@
       </p:sp>
       <p:sp>
         <p:nvSpPr>
-          <p:cNvPr id="6" name="Text 4"/>
+          <p:cNvPr id="7" name="Text 4"/>
           <p:cNvSpPr txBox="1"/>
           <p:nvPr/>
         </p:nvSpPr>
@@ -3258,7 +3282,7 @@
       </p:sp>
       <p:sp>
         <p:nvSpPr>
-          <p:cNvPr id="7" name="Text 5"/>
+          <p:cNvPr id="8" name="Text 5"/>
           <p:cNvSpPr txBox="1"/>
           <p:nvPr/>
         </p:nvSpPr>
@@ -3839,7 +3863,7 @@
                           <a:ea typeface="Calibri" pitchFamily="34" charset="-122"/>
                           <a:cs typeface="Calibri" pitchFamily="34" charset="-120"/>
                         </a:rPr>
-                        <a:t>−9 960</a:t>
+                        <a:t>−9,960</a:t>
                       </a:r>
                       <a:endParaRPr lang="en-US" sz="1250" dirty="0">
                         <a:latin typeface="Calibri" charset="0"/>
@@ -4253,7 +4277,7 @@
                           <a:ea typeface="Calibri" pitchFamily="34" charset="-122"/>
                           <a:cs typeface="Calibri" pitchFamily="34" charset="-120"/>
                         </a:rPr>
-                        <a:t>−2 515</a:t>
+                        <a:t>−2,515</a:t>
                       </a:r>
                       <a:endParaRPr lang="en-US" sz="1250" dirty="0">
                         <a:latin typeface="Calibri" charset="0"/>
@@ -4697,7 +4721,7 @@
                           <a:ea typeface="Calibri" pitchFamily="34" charset="-122"/>
                           <a:cs typeface="Calibri" pitchFamily="34" charset="-120"/>
                         </a:rPr>
-                        <a:t>−61 095</a:t>
+                        <a:t>−61,095</a:t>
                       </a:r>
                       <a:endParaRPr lang="en-US" sz="1250" dirty="0">
                         <a:latin typeface="Calibri" charset="0"/>
@@ -4904,7 +4928,7 @@
                           <a:ea typeface="Calibri" pitchFamily="34" charset="-122"/>
                           <a:cs typeface="Calibri" pitchFamily="34" charset="-120"/>
                         </a:rPr>
-                        <a:t>+2 128</a:t>
+                        <a:t>+2,128</a:t>
                       </a:r>
                       <a:endParaRPr lang="en-US" sz="1250" dirty="0">
                         <a:latin typeface="Calibri" charset="0"/>
@@ -5129,7 +5153,7 @@
                           <a:ea typeface="Calibri" pitchFamily="34" charset="-122"/>
                           <a:cs typeface="Calibri" pitchFamily="34" charset="-120"/>
                         </a:rPr>
-                        <a:t>−31 077</a:t>
+                        <a:t>−31,077</a:t>
                       </a:r>
                       <a:endParaRPr lang="en-US" sz="1250" dirty="0">
                         <a:latin typeface="Calibri" charset="0"/>
@@ -5348,7 +5372,7 @@
                           <a:ea typeface="Calibri" pitchFamily="34" charset="-122"/>
                           <a:cs typeface="Calibri" pitchFamily="34" charset="-120"/>
                         </a:rPr>
-                        <a:t>+425 344</a:t>
+                        <a:t>+425,344</a:t>
                       </a:r>
                       <a:endParaRPr lang="en-US" sz="1250" dirty="0">
                         <a:latin typeface="Calibri" charset="0"/>
@@ -5555,7 +5579,7 @@
                           <a:ea typeface="Calibri" pitchFamily="34" charset="-122"/>
                           <a:cs typeface="Calibri" pitchFamily="34" charset="-120"/>
                         </a:rPr>
-                        <a:t>+233 811</a:t>
+                        <a:t>+233,811</a:t>
                       </a:r>
                       <a:endParaRPr lang="en-US" sz="1250" dirty="0">
                         <a:latin typeface="Calibri" charset="0"/>
@@ -5780,7 +5804,7 @@
                           <a:ea typeface="Calibri" pitchFamily="34" charset="-122"/>
                           <a:cs typeface="Calibri" pitchFamily="34" charset="-120"/>
                         </a:rPr>
-                        <a:t>+121 598</a:t>
+                        <a:t>+121,598</a:t>
                       </a:r>
                       <a:endParaRPr lang="en-US" sz="1250" dirty="0">
                         <a:latin typeface="Calibri" charset="0"/>
@@ -5895,7 +5919,7 @@
                 <a:ea typeface="Calibri" pitchFamily="34" charset="-122"/>
                 <a:cs typeface="Calibri" pitchFamily="34" charset="-120"/>
               </a:rPr>
-              <a:t>Hendeku = seed-i më i dobët i fituesit minus seed-i më i mirë i të dytit. I vendosur = hendek pozitiv dhe i njëjti fitues sipas medianës: çdo seed i fituesit mposht çdo seed të çdo rivali (test i saktë rangjesh, p = 0,05 me tre seed-a). * synth-3: 71 HV mbi pikën e vet të nisjes.</a:t>
+              <a:t>Hendeku = seed-i më i dobët i fituesit minus seed-i më i mirë i të dytit. I vendosur = hendek pozitiv dhe i njëjti fitues sipas medianës: çdo seed i fituesit mposht çdo seed të çdo rivali (test i saktë rangjesh, p = 0.05 me tre seed-a). * synth-3: 71 HV mbi pikën e vet të nisjes.</a:t>
             </a:r>
             <a:endParaRPr lang="en-US" sz="1050" dirty="0"/>
           </a:p>
@@ -6638,7 +6662,7 @@
                 <a:ea typeface="Calibri" pitchFamily="34" charset="-122"/>
                 <a:cs typeface="Calibri" pitchFamily="34" charset="-120"/>
               </a:rPr>
-              <a:t>1 810</a:t>
+              <a:t>1,810</a:t>
             </a:r>
             <a:endParaRPr lang="en-US" sz="1000" dirty="0"/>
           </a:p>
@@ -6677,7 +6701,7 @@
                 <a:ea typeface="Calibri" pitchFamily="34" charset="-122"/>
                 <a:cs typeface="Calibri" pitchFamily="34" charset="-120"/>
               </a:rPr>
-              <a:t>1 815</a:t>
+              <a:t>1,815</a:t>
             </a:r>
             <a:endParaRPr lang="en-US" sz="1000" dirty="0"/>
           </a:p>
@@ -6716,7 +6740,7 @@
                 <a:ea typeface="Calibri" pitchFamily="34" charset="-122"/>
                 <a:cs typeface="Calibri" pitchFamily="34" charset="-120"/>
               </a:rPr>
-              <a:t>1 820</a:t>
+              <a:t>1,820</a:t>
             </a:r>
             <a:endParaRPr lang="en-US" sz="1000" dirty="0"/>
           </a:p>
@@ -6755,7 +6779,7 @@
                 <a:ea typeface="Calibri" pitchFamily="34" charset="-122"/>
                 <a:cs typeface="Calibri" pitchFamily="34" charset="-120"/>
               </a:rPr>
-              <a:t>1 825</a:t>
+              <a:t>1,825</a:t>
             </a:r>
             <a:endParaRPr lang="en-US" sz="1000" dirty="0"/>
           </a:p>
@@ -6794,7 +6818,7 @@
                 <a:ea typeface="Calibri" pitchFamily="34" charset="-122"/>
                 <a:cs typeface="Calibri" pitchFamily="34" charset="-120"/>
               </a:rPr>
-              <a:t>hipervolumi ×1 000</a:t>
+              <a:t>hipervolumi ×1,000</a:t>
             </a:r>
             <a:endParaRPr lang="en-US" sz="1000" dirty="0"/>
           </a:p>
@@ -7274,7 +7298,7 @@
                 <a:ea typeface="Calibri" pitchFamily="34" charset="-122"/>
                 <a:cs typeface="Calibri" pitchFamily="34" charset="-120"/>
               </a:rPr>
-              <a:t>kontrolli i rimostruar: ±21 519 HV</a:t>
+              <a:t>kontrolli i rimostruar: ±21,519 HV</a:t>
             </a:r>
             <a:endParaRPr lang="en-US" sz="1050" dirty="0"/>
           </a:p>
@@ -7614,7 +7638,7 @@
                 <a:ea typeface="Calibri" pitchFamily="34" charset="-122"/>
                 <a:cs typeface="Calibri" pitchFamily="34" charset="-120"/>
               </a:rPr>
-              <a:t>+9 562  ·  0,4×</a:t>
+              <a:t>+9,562  ·  0.4×</a:t>
             </a:r>
             <a:endParaRPr lang="en-US" sz="1200" dirty="0"/>
           </a:p>
@@ -7775,7 +7799,7 @@
                 <a:ea typeface="Calibri" pitchFamily="34" charset="-122"/>
                 <a:cs typeface="Calibri" pitchFamily="34" charset="-120"/>
               </a:rPr>
-              <a:t>+19 623  ·  0,9×</a:t>
+              <a:t>+19,623  ·  0.9×</a:t>
             </a:r>
             <a:endParaRPr lang="en-US" sz="1200" dirty="0"/>
           </a:p>
@@ -7936,7 +7960,7 @@
                 <a:ea typeface="Calibri" pitchFamily="34" charset="-122"/>
                 <a:cs typeface="Calibri" pitchFamily="34" charset="-120"/>
               </a:rPr>
-              <a:t>+42 468  ·  2,0×</a:t>
+              <a:t>+42,468  ·  2.0×</a:t>
             </a:r>
             <a:endParaRPr lang="en-US" sz="1200" dirty="0"/>
           </a:p>
@@ -8095,7 +8119,7 @@
                 <a:ea typeface="Calibri" pitchFamily="34" charset="-122"/>
                 <a:cs typeface="Calibri" pitchFamily="34" charset="-120"/>
               </a:rPr>
-              <a:t>+341 263  ·  15,9×</a:t>
+              <a:t>+341,263  ·  15.9×</a:t>
             </a:r>
             <a:endParaRPr lang="en-US" sz="1200" dirty="0"/>
           </a:p>
@@ -8293,7 +8317,7 @@
                 <a:ea typeface="Century Schoolbook" pitchFamily="34" charset="-122"/>
                 <a:cs typeface="Century Schoolbook" pitchFamily="34" charset="-120"/>
               </a:rPr>
-              <a:t>+343 623 HV</a:t>
+              <a:t>+343,623 HV</a:t>
             </a:r>
             <a:endParaRPr lang="en-US" sz="2500" dirty="0"/>
           </a:p>
@@ -8371,7 +8395,7 @@
                 <a:ea typeface="Century Schoolbook" pitchFamily="34" charset="-122"/>
                 <a:cs typeface="Century Schoolbook" pitchFamily="34" charset="-120"/>
               </a:rPr>
-              <a:t>−2 360 HV</a:t>
+              <a:t>−2,360 HV</a:t>
             </a:r>
             <a:endParaRPr lang="en-US" sz="2500" dirty="0"/>
           </a:p>
@@ -8750,7 +8774,7 @@
                 <a:ea typeface="Calibri" pitchFamily="34" charset="-122"/>
                 <a:cs typeface="Calibri" pitchFamily="34" charset="-120"/>
               </a:rPr>
-              <a:t>kontrolli i rimostruar  ±21 519 HV</a:t>
+              <a:t>kontrolli i rimostruar  ±21,519 HV</a:t>
             </a:r>
             <a:endParaRPr lang="en-US" sz="1050" dirty="0"/>
           </a:p>
@@ -10544,7 +10568,7 @@
                 <a:ea typeface="Century Schoolbook" pitchFamily="34" charset="-122"/>
                 <a:cs typeface="Century Schoolbook" pitchFamily="34" charset="-120"/>
               </a:rPr>
-              <a:t>0,23%</a:t>
+              <a:t>0.23%</a:t>
             </a:r>
             <a:endParaRPr lang="en-US" sz="5400" dirty="0"/>
           </a:p>
@@ -10839,7 +10863,7 @@
                 <a:ea typeface="Calibri" pitchFamily="34" charset="-122"/>
                 <a:cs typeface="Calibri" pitchFamily="34" charset="-120"/>
               </a:rPr>
-              <a:t>26,4M</a:t>
+              <a:t>26.4M</a:t>
             </a:r>
             <a:endParaRPr lang="en-US" sz="1000" dirty="0"/>
           </a:p>
@@ -10901,7 +10925,7 @@
                 <a:ea typeface="Calibri" pitchFamily="34" charset="-122"/>
                 <a:cs typeface="Calibri" pitchFamily="34" charset="-120"/>
               </a:rPr>
-              <a:t>26,5M</a:t>
+              <a:t>26.5M</a:t>
             </a:r>
             <a:endParaRPr lang="en-US" sz="1000" dirty="0"/>
           </a:p>
@@ -10963,7 +10987,7 @@
                 <a:ea typeface="Calibri" pitchFamily="34" charset="-122"/>
                 <a:cs typeface="Calibri" pitchFamily="34" charset="-120"/>
               </a:rPr>
-              <a:t>26,6M</a:t>
+              <a:t>26.6M</a:t>
             </a:r>
             <a:endParaRPr lang="en-US" sz="1000" dirty="0"/>
           </a:p>
@@ -11025,7 +11049,7 @@
                 <a:ea typeface="Calibri" pitchFamily="34" charset="-122"/>
                 <a:cs typeface="Calibri" pitchFamily="34" charset="-120"/>
               </a:rPr>
-              <a:t>26,7M</a:t>
+              <a:t>26.7M</a:t>
             </a:r>
             <a:endParaRPr lang="en-US" sz="1000" dirty="0"/>
           </a:p>
@@ -11087,7 +11111,7 @@
                 <a:ea typeface="Calibri" pitchFamily="34" charset="-122"/>
                 <a:cs typeface="Calibri" pitchFamily="34" charset="-120"/>
               </a:rPr>
-              <a:t>26,8M</a:t>
+              <a:t>26.8M</a:t>
             </a:r>
             <a:endParaRPr lang="en-US" sz="1000" dirty="0"/>
           </a:p>
@@ -11165,7 +11189,7 @@
                 <a:ea typeface="Calibri" pitchFamily="34" charset="-122"/>
                 <a:cs typeface="Calibri" pitchFamily="34" charset="-120"/>
               </a:rPr>
-              <a:t>1 200 s</a:t>
+              <a:t>1,200 s</a:t>
             </a:r>
             <a:endParaRPr lang="en-US" sz="1050" dirty="0"/>
           </a:p>
@@ -11204,7 +11228,7 @@
                 <a:ea typeface="Calibri" pitchFamily="34" charset="-122"/>
                 <a:cs typeface="Calibri" pitchFamily="34" charset="-120"/>
               </a:rPr>
-              <a:t>3 600 s</a:t>
+              <a:t>3,600 s</a:t>
             </a:r>
             <a:endParaRPr lang="en-US" sz="1050" dirty="0"/>
           </a:p>
@@ -11243,7 +11267,7 @@
                 <a:ea typeface="Calibri" pitchFamily="34" charset="-122"/>
                 <a:cs typeface="Calibri" pitchFamily="34" charset="-120"/>
               </a:rPr>
-              <a:t>12 000 s</a:t>
+              <a:t>12,000 s</a:t>
             </a:r>
             <a:endParaRPr lang="en-US" sz="1050" dirty="0"/>
           </a:p>
@@ -11887,7 +11911,7 @@
                 <a:ea typeface="Calibri" pitchFamily="34" charset="-122"/>
                 <a:cs typeface="Calibri" pitchFamily="34" charset="-120"/>
               </a:rPr>
-              <a:t>epërsia ≥ 269 607 HV</a:t>
+              <a:t>epërsia ≥ 269,607 HV</a:t>
             </a:r>
             <a:endParaRPr lang="en-US" sz="1200" dirty="0"/>
           </a:p>
@@ -11943,7 +11967,7 @@
                 <a:ea typeface="Calibri" pitchFamily="34" charset="-122"/>
                 <a:cs typeface="Calibri" pitchFamily="34" charset="-120"/>
               </a:rPr>
-              <a:t>+33 043 HV mbi 10×</a:t>
+              <a:t>+33,043 HV mbi 10×</a:t>
             </a:r>
             <a:endParaRPr lang="en-US" sz="1150" dirty="0"/>
           </a:p>
@@ -11960,7 +11984,7 @@
                 <a:ea typeface="Calibri" pitchFamily="34" charset="-122"/>
                 <a:cs typeface="Calibri" pitchFamily="34" charset="-120"/>
               </a:rPr>
-              <a:t>≈ 1,5× rimostrimi i kontrollit</a:t>
+              <a:t>≈ 1.5× rimostrimi i kontrollit</a:t>
             </a:r>
             <a:endParaRPr lang="en-US" sz="1150" dirty="0"/>
           </a:p>
@@ -12700,7 +12724,7 @@
                 <a:ea typeface="Calibri" pitchFamily="34" charset="-122"/>
                 <a:cs typeface="Calibri" pitchFamily="34" charset="-120"/>
               </a:rPr>
-              <a:t>Dy sesione, jo dy seed-a. Totali ynë i dhjetë instancave lëvizi 21 519 HV.</a:t>
+              <a:t>Dy sesione, jo dy seed-a. Totali ynë i dhjetë instancave lëvizi 21,519 HV.</a:t>
             </a:r>
             <a:endParaRPr lang="en-US" sz="1400" dirty="0"/>
           </a:p>
@@ -13072,9 +13096,33 @@
           <a:chExt cx="0" cy="0"/>
         </a:xfrm>
       </p:grpSpPr>
-      <p:sp>
-        <p:nvSpPr>
-          <p:cNvPr id="2" name="Text 0"/>
+      <p:pic>
+        <p:nvPicPr>
+          <p:cNvPr id="2" name="Image 0" descr="Universiteti i Prishtinës">    </p:cNvPr>
+          <p:cNvPicPr>
+            <a:picLocks noChangeAspect="1"/>
+          </p:cNvPicPr>
+          <p:nvPr/>
+        </p:nvPicPr>
+        <p:blipFill>
+          <a:blip r:embed="rId1"/>
+          <a:stretch>
+            <a:fillRect/>
+          </a:stretch>
+        </p:blipFill>
+        <p:spPr>
+          <a:xfrm>
+            <a:off x="640080" y="274320"/>
+            <a:ext cx="713232" cy="713232"/>
+          </a:xfrm>
+          <a:prstGeom prst="rect">
+            <a:avLst/>
+          </a:prstGeom>
+        </p:spPr>
+      </p:pic>
+      <p:sp>
+        <p:nvSpPr>
+          <p:cNvPr id="3" name="Text 0"/>
           <p:cNvSpPr txBox="1"/>
           <p:nvPr/>
         </p:nvSpPr>
@@ -13113,7 +13161,7 @@
       </p:sp>
       <p:sp>
         <p:nvSpPr>
-          <p:cNvPr id="3" name="Text 1"/>
+          <p:cNvPr id="4" name="Text 1"/>
           <p:cNvSpPr txBox="1"/>
           <p:nvPr/>
         </p:nvSpPr>
@@ -13152,7 +13200,7 @@
       </p:sp>
       <p:sp>
         <p:nvSpPr>
-          <p:cNvPr id="4" name="Text 2"/>
+          <p:cNvPr id="5" name="Text 2"/>
           <p:cNvSpPr txBox="1"/>
           <p:nvPr/>
         </p:nvSpPr>
@@ -13191,7 +13239,7 @@
       </p:sp>
       <p:sp>
         <p:nvSpPr>
-          <p:cNvPr id="5" name="Text 3"/>
+          <p:cNvPr id="6" name="Text 3"/>
           <p:cNvSpPr txBox="1"/>
           <p:nvPr/>
         </p:nvSpPr>
@@ -13230,7 +13278,7 @@
       </p:sp>
       <p:sp>
         <p:nvSpPr>
-          <p:cNvPr id="6" name="Text 4"/>
+          <p:cNvPr id="7" name="Text 4"/>
           <p:cNvSpPr txBox="1"/>
           <p:nvPr/>
         </p:nvSpPr>
@@ -13269,7 +13317,7 @@
       </p:sp>
       <p:sp>
         <p:nvSpPr>
-          <p:cNvPr id="7" name="Text 5"/>
+          <p:cNvPr id="8" name="Text 5"/>
           <p:cNvSpPr txBox="1"/>
           <p:nvPr/>
         </p:nvSpPr>
@@ -13300,7 +13348,7 @@
                 <a:ea typeface="Century Schoolbook" pitchFamily="34" charset="-122"/>
                 <a:cs typeface="Century Schoolbook" pitchFamily="34" charset="-120"/>
               </a:rPr>
-              <a:t>15,9×</a:t>
+              <a:t>15.9×</a:t>
             </a:r>
             <a:endParaRPr lang="en-US" sz="1900" dirty="0"/>
           </a:p>
@@ -13308,7 +13356,7 @@
       </p:sp>
       <p:sp>
         <p:nvSpPr>
-          <p:cNvPr id="8" name="Text 6"/>
+          <p:cNvPr id="9" name="Text 6"/>
           <p:cNvSpPr txBox="1"/>
           <p:nvPr/>
         </p:nvSpPr>
@@ -13339,7 +13387,7 @@
                 <a:ea typeface="Calibri" pitchFamily="34" charset="-122"/>
                 <a:cs typeface="Calibri" pitchFamily="34" charset="-120"/>
               </a:rPr>
-              <a:t>ndërtimi kundër rimostrimit të kontrollit; variantet e kërkimit 0,4–2,0×</a:t>
+              <a:t>ndërtimi kundër rimostrimit të kontrollit; variantet e kërkimit 0.4–2.0×</a:t>
             </a:r>
             <a:endParaRPr lang="en-US" sz="1050" dirty="0"/>
           </a:p>
@@ -13347,7 +13395,7 @@
       </p:sp>
       <p:sp>
         <p:nvSpPr>
-          <p:cNvPr id="9" name="Text 7"/>
+          <p:cNvPr id="10" name="Text 7"/>
           <p:cNvSpPr txBox="1"/>
           <p:nvPr/>
         </p:nvSpPr>
@@ -13378,7 +13426,7 @@
                 <a:ea typeface="Century Schoolbook" pitchFamily="34" charset="-122"/>
                 <a:cs typeface="Century Schoolbook" pitchFamily="34" charset="-120"/>
               </a:rPr>
-              <a:t>21 519 HV</a:t>
+              <a:t>21,519 HV</a:t>
             </a:r>
             <a:endParaRPr lang="en-US" sz="1900" dirty="0"/>
           </a:p>
@@ -13386,7 +13434,7 @@
       </p:sp>
       <p:sp>
         <p:nvSpPr>
-          <p:cNvPr id="10" name="Text 8"/>
+          <p:cNvPr id="11" name="Text 8"/>
           <p:cNvSpPr txBox="1"/>
           <p:nvPr/>
         </p:nvSpPr>
@@ -13417,7 +13465,7 @@
                 <a:ea typeface="Calibri" pitchFamily="34" charset="-122"/>
                 <a:cs typeface="Calibri" pitchFamily="34" charset="-120"/>
               </a:rPr>
-              <a:t>zhvendosja mes sesioneve e totalit të dhjetë instancave (p ≈ 0,05)</a:t>
+              <a:t>zhvendosja mes sesioneve e totalit të dhjetë instancave (p ≈ 0.05)</a:t>
             </a:r>
             <a:endParaRPr lang="en-US" sz="1050" dirty="0"/>
           </a:p>
@@ -13425,7 +13473,7 @@
       </p:sp>
       <p:sp>
         <p:nvSpPr>
-          <p:cNvPr id="11" name="Text 9"/>
+          <p:cNvPr id="12" name="Text 9"/>
           <p:cNvSpPr txBox="1"/>
           <p:nvPr/>
         </p:nvSpPr>
@@ -13456,7 +13504,7 @@
                 <a:ea typeface="Century Schoolbook" pitchFamily="34" charset="-122"/>
                 <a:cs typeface="Century Schoolbook" pitchFamily="34" charset="-120"/>
               </a:rPr>
-              <a:t>0,23%</a:t>
+              <a:t>0.23%</a:t>
             </a:r>
             <a:endParaRPr lang="en-US" sz="1900" dirty="0"/>
           </a:p>
@@ -13464,7 +13512,7 @@
       </p:sp>
       <p:sp>
         <p:nvSpPr>
-          <p:cNvPr id="12" name="Text 10"/>
+          <p:cNvPr id="13" name="Text 10"/>
           <p:cNvSpPr txBox="1"/>
           <p:nvPr/>
         </p:nvSpPr>
@@ -13503,7 +13551,7 @@
       </p:sp>
       <p:sp>
         <p:nvSpPr>
-          <p:cNvPr id="13" name="Text 11"/>
+          <p:cNvPr id="14" name="Text 11"/>
           <p:cNvSpPr txBox="1"/>
           <p:nvPr/>
         </p:nvSpPr>
@@ -13534,7 +13582,7 @@
                 <a:ea typeface="Century Schoolbook" pitchFamily="34" charset="-122"/>
                 <a:cs typeface="Century Schoolbook" pitchFamily="34" charset="-120"/>
               </a:rPr>
-              <a:t>+33 043 HV</a:t>
+              <a:t>+33,043 HV</a:t>
             </a:r>
             <a:endParaRPr lang="en-US" sz="1900" dirty="0"/>
           </a:p>
@@ -13542,7 +13590,7 @@
       </p:sp>
       <p:sp>
         <p:nvSpPr>
-          <p:cNvPr id="14" name="Text 12"/>
+          <p:cNvPr id="15" name="Text 12"/>
           <p:cNvSpPr txBox="1"/>
           <p:nvPr/>
         </p:nvSpPr>
@@ -13573,7 +13621,7 @@
                 <a:ea typeface="Calibri" pitchFamily="34" charset="-122"/>
                 <a:cs typeface="Calibri" pitchFamily="34" charset="-120"/>
               </a:rPr>
-              <a:t>çfarë i blen kërkimit dhjetëfishi i buxhetit, kundër një epërsie ≥ 269 607</a:t>
+              <a:t>çfarë i blen kërkimit dhjetëfishi i buxhetit, kundër një epërsie ≥ 269,607</a:t>
             </a:r>
             <a:endParaRPr lang="en-US" sz="1050" dirty="0"/>
           </a:p>
@@ -13581,7 +13629,7 @@
       </p:sp>
       <p:sp>
         <p:nvSpPr>
-          <p:cNvPr id="15" name="Text 13"/>
+          <p:cNvPr id="16" name="Text 13"/>
           <p:cNvSpPr txBox="1"/>
           <p:nvPr/>
         </p:nvSpPr>
@@ -13612,7 +13660,7 @@
                 <a:ea typeface="Century Schoolbook" pitchFamily="34" charset="-122"/>
                 <a:cs typeface="Century Schoolbook" pitchFamily="34" charset="-120"/>
               </a:rPr>
-              <a:t>0,63%</a:t>
+              <a:t>0.63%</a:t>
             </a:r>
             <a:endParaRPr lang="en-US" sz="1900" dirty="0"/>
           </a:p>
@@ -13620,7 +13668,7 @@
       </p:sp>
       <p:sp>
         <p:nvSpPr>
-          <p:cNvPr id="16" name="Text 14"/>
+          <p:cNvPr id="17" name="Text 14"/>
           <p:cNvSpPr txBox="1"/>
           <p:nvPr/>
         </p:nvSpPr>
@@ -13659,7 +13707,7 @@
       </p:sp>
       <p:sp>
         <p:nvSpPr>
-          <p:cNvPr id="17" name="Text 15"/>
+          <p:cNvPr id="18" name="Text 15"/>
           <p:cNvSpPr txBox="1"/>
           <p:nvPr/>
         </p:nvSpPr>
@@ -13698,7 +13746,7 @@
       </p:sp>
       <p:sp>
         <p:nvSpPr>
-          <p:cNvPr id="18" name="Text 16"/>
+          <p:cNvPr id="19" name="Text 16"/>
           <p:cNvSpPr txBox="1"/>
           <p:nvPr/>
         </p:nvSpPr>
@@ -13953,7 +14001,7 @@
                 <a:ea typeface="Calibri" pitchFamily="34" charset="-122"/>
                 <a:cs typeface="Calibri" pitchFamily="34" charset="-120"/>
               </a:rPr>
-              <a:t>hill_climbing.py i zgjidhte gjerësitë e synuara me një sondë min-degree pavarësisht nisjes së kërkuar, prandaj --start random merrte fshehtas një zgjidhje min-degree: 1 607 522 HV në medium-graph për një ekzekutim pa asnjë lëvizje të pranuar.</a:t>
+              <a:t>hill_climbing.py i zgjidhte gjerësitë e synuara me një sondë min-degree pavarësisht nisjes së kërkuar, prandaj --start random merrte fshehtas një zgjidhje min-degree: 1,607,522 HV në medium-graph për një ekzekutim pa asnjë lëvizje të pranuar.</a:t>
             </a:r>
             <a:endParaRPr lang="en-US" sz="1150" dirty="0"/>
           </a:p>
@@ -14328,7 +14376,7 @@
                 <a:ea typeface="Calibri" pitchFamily="34" charset="-122"/>
                 <a:cs typeface="Calibri" pitchFamily="34" charset="-120"/>
               </a:rPr>
-              <a:t>Vlerësuesi CUDA i përfshirë indeksonte një varg B×N×N me një zhvendosje int, që mbështillet pas 2³¹ në n = 2 426, fija 365 nga 1 024.</a:t>
+              <a:t>Vlerësuesi CUDA i përfshirë indeksonte një varg B×N×N me një zhvendosje int, që mbështillet pas 2³¹ në n = 2,426, fija 365 nga 1,024.</a:t>
             </a:r>
             <a:endParaRPr lang="en-US" sz="1150" dirty="0"/>
           </a:p>
@@ -14367,7 +14415,7 @@
                 <a:ea typeface="Calibri" pitchFamily="34" charset="-122"/>
                 <a:cs typeface="Calibri" pitchFamily="34" charset="-120"/>
               </a:rPr>
-              <a:t>U kap sepse çdo ekzekutim me n = 2 426 dështonte herët me një qasje të paligjshme në memorie; një ndryshim tipi e rregulloi.</a:t>
+              <a:t>U kap sepse çdo ekzekutim me n = 2,426 dështonte herët me një qasje të paligjshme në memorie; një ndryshim tipi e rregulloi.</a:t>
             </a:r>
             <a:endParaRPr lang="en-US" sz="1150" dirty="0"/>
           </a:p>
@@ -14507,7 +14555,7 @@
                 <a:ea typeface="Calibri" pitchFamily="34" charset="-122"/>
                 <a:cs typeface="Calibri" pitchFamily="34" charset="-120"/>
               </a:rPr>
-              <a:t>Një prag prej 7 881 HV, i marrë nga instanca më e keqe e Hill Climbing, gjykoi rreshtat e çdo metode, ndërsa seed-at e vetë Team HRI në medium-graph shpërndahen 80 376 HV.</a:t>
+              <a:t>Një prag prej 7,881 HV, i marrë nga instanca më e keqe e Hill Climbing, gjykoi rreshtat e çdo metode, ndërsa seed-at e vetë Team HRI në medium-graph shpërndahen 80,376 HV.</a:t>
             </a:r>
             <a:endParaRPr lang="en-US" sz="1150" dirty="0"/>
           </a:p>
@@ -14818,7 +14866,7 @@
                 <a:ea typeface="Calibri" pitchFamily="34" charset="-122"/>
                 <a:cs typeface="Calibri" pitchFamily="34" charset="-120"/>
               </a:rPr>
-              <a:t>1 200 s kohë reale për ekzekutim, tre seed-a, dhjetë instanca. Katër ekzekutime ranë jashtë 1 150–1 400 s pas ngecjeve të makinës; asnjë prej tyre nuk e jep vlerën më të mirë nga tre.</a:t>
+              <a:t>1,200 s kohë reale për ekzekutim, tre seed-a, dhjetë instanca. Katër ekzekutime ranë jashtë 1,150–1,400 s pas ngecjeve të makinës; asnjë prej tyre nuk e jep vlerën më të mirë nga tre.</a:t>
             </a:r>
             <a:endParaRPr lang="en-US" sz="1300" dirty="0"/>
           </a:p>
@@ -14919,7 +14967,7 @@
                 <a:ea typeface="Calibri" pitchFamily="34" charset="-122"/>
                 <a:cs typeface="Calibri" pitchFamily="34" charset="-120"/>
               </a:rPr>
-              <a:t>fcmaes, Team HRI dhe Hill Climbing në një bërthamë CPU të fiksuar secili. Spacekangaroos me kodin e vet CUDA në një Kaggle T4, batch 1 024 (512 në n = 2 426).</a:t>
+              <a:t>fcmaes, Team HRI dhe Hill Climbing në një bërthamë CPU të fiksuar secili. Spacekangaroos me kodin e vet CUDA në një Kaggle T4, batch 1,024 (512 në n = 2,426).</a:t>
             </a:r>
             <a:endParaRPr lang="en-US" sz="1300" dirty="0"/>
           </a:p>
@@ -15222,7 +15270,7 @@
                 <a:ea typeface="Calibri" pitchFamily="34" charset="-122"/>
                 <a:cs typeface="Calibri" pitchFamily="34" charset="-120"/>
               </a:rPr>
-              <a:t>Çdo përgjigje rivlerësohet me esa_eval.py. Kodi i vlerësimit i ESA-s, i ekzekutuar pranë tij, përputhet në të dhjetë instancat: 220 renditje, 2 000 hipervolume, kolona min-degree ×8. ESA e vlerëson me gjerësi 501 një vektor mbi kufi; ne e hedhim dorëzimin.</a:t>
+              <a:t>Çdo përgjigje rivlerësohet me esa_eval.py. Kodi i vlerësimit i ESA-s, i ekzekutuar pranë tij, përputhet në të dhjetë instancat: 220 renditje, 2,000 hipervolume, kolona min-degree ×8. ESA e vlerëson me gjerësi 501 një vektor mbi kufi; ne e hedhim dorëzimin.</a:t>
             </a:r>
             <a:endParaRPr lang="en-US" sz="1300" dirty="0"/>
           </a:p>
@@ -16516,7 +16564,7 @@
                           <a:ea typeface="Calibri" pitchFamily="34" charset="-122"/>
                           <a:cs typeface="Calibri" pitchFamily="34" charset="-120"/>
                         </a:rPr>
-                        <a:t>1 807,7</a:t>
+                        <a:t>1,807.7</a:t>
                       </a:r>
                       <a:endParaRPr lang="en-US" sz="1050" dirty="0">
                         <a:latin typeface="Calibri" charset="0"/>
@@ -16557,7 +16605,7 @@
                           <a:ea typeface="Calibri" pitchFamily="34" charset="-122"/>
                           <a:cs typeface="Calibri" pitchFamily="34" charset="-120"/>
                         </a:rPr>
-                        <a:t>1 808,0</a:t>
+                        <a:t>1,808.0</a:t>
                       </a:r>
                       <a:endParaRPr lang="en-US" sz="1050" dirty="0">
                         <a:latin typeface="Calibri" charset="0"/>
@@ -16598,7 +16646,7 @@
                           <a:ea typeface="Calibri" pitchFamily="34" charset="-122"/>
                           <a:cs typeface="Calibri" pitchFamily="34" charset="-120"/>
                         </a:rPr>
-                        <a:t>1 807,1</a:t>
+                        <a:t>1,807.1</a:t>
                       </a:r>
                       <a:endParaRPr lang="en-US" sz="1050" dirty="0">
                         <a:latin typeface="Calibri" charset="0"/>
@@ -16639,7 +16687,7 @@
                           <a:ea typeface="Calibri" pitchFamily="34" charset="-122"/>
                           <a:cs typeface="Calibri" pitchFamily="34" charset="-120"/>
                         </a:rPr>
-                        <a:t>1 820,9</a:t>
+                        <a:t>1,820.9</a:t>
                       </a:r>
                       <a:endParaRPr lang="en-US" sz="1050" dirty="0">
                         <a:latin typeface="Calibri" charset="0"/>
@@ -16680,7 +16728,7 @@
                           <a:ea typeface="Calibri" pitchFamily="34" charset="-122"/>
                           <a:cs typeface="Calibri" pitchFamily="34" charset="-120"/>
                         </a:rPr>
-                        <a:t>1 819,5</a:t>
+                        <a:t>1,819.5</a:t>
                       </a:r>
                       <a:endParaRPr lang="en-US" sz="1050" dirty="0">
                         <a:latin typeface="Calibri" charset="0"/>
@@ -16721,7 +16769,7 @@
                           <a:ea typeface="Calibri" pitchFamily="34" charset="-122"/>
                           <a:cs typeface="Calibri" pitchFamily="34" charset="-120"/>
                         </a:rPr>
-                        <a:t>1 818,9</a:t>
+                        <a:t>1,818.9</a:t>
                       </a:r>
                       <a:endParaRPr lang="en-US" sz="1050" dirty="0">
                         <a:latin typeface="Calibri" charset="0"/>
@@ -16762,7 +16810,7 @@
                           <a:ea typeface="Calibri" pitchFamily="34" charset="-122"/>
                           <a:cs typeface="Calibri" pitchFamily="34" charset="-120"/>
                         </a:rPr>
-                        <a:t>1 827,5</a:t>
+                        <a:t>1,827.5</a:t>
                       </a:r>
                       <a:endParaRPr lang="en-US" sz="1050" dirty="0">
                         <a:latin typeface="Calibri" charset="0"/>
@@ -16803,7 +16851,7 @@
                           <a:ea typeface="Calibri" pitchFamily="34" charset="-122"/>
                           <a:cs typeface="Calibri" pitchFamily="34" charset="-120"/>
                         </a:rPr>
-                        <a:t>1 812,2</a:t>
+                        <a:t>1,812.2</a:t>
                       </a:r>
                       <a:endParaRPr lang="en-US" sz="1050" dirty="0">
                         <a:latin typeface="Calibri" charset="0"/>
@@ -16844,7 +16892,7 @@
                           <a:ea typeface="Calibri" pitchFamily="34" charset="-122"/>
                           <a:cs typeface="Calibri" pitchFamily="34" charset="-120"/>
                         </a:rPr>
-                        <a:t>1 810,9</a:t>
+                        <a:t>1,810.9</a:t>
                       </a:r>
                       <a:endParaRPr lang="en-US" sz="1050" dirty="0">
                         <a:latin typeface="Calibri" charset="0"/>
@@ -16885,7 +16933,7 @@
                           <a:ea typeface="Calibri" pitchFamily="34" charset="-122"/>
                           <a:cs typeface="Calibri" pitchFamily="34" charset="-120"/>
                         </a:rPr>
-                        <a:t>1 814,5</a:t>
+                        <a:t>1,814.5</a:t>
                       </a:r>
                       <a:endParaRPr lang="en-US" sz="1050" dirty="0">
                         <a:latin typeface="Calibri" charset="0"/>
@@ -16926,7 +16974,7 @@
                           <a:ea typeface="Calibri" pitchFamily="34" charset="-122"/>
                           <a:cs typeface="Calibri" pitchFamily="34" charset="-120"/>
                         </a:rPr>
-                        <a:t>1 815,4</a:t>
+                        <a:t>1,815.4</a:t>
                       </a:r>
                       <a:endParaRPr lang="en-US" sz="1050" dirty="0">
                         <a:latin typeface="Calibri" charset="0"/>
@@ -16967,7 +17015,7 @@
                           <a:ea typeface="Calibri" pitchFamily="34" charset="-122"/>
                           <a:cs typeface="Calibri" pitchFamily="34" charset="-120"/>
                         </a:rPr>
-                        <a:t>1 814,5</a:t>
+                        <a:t>1,814.5</a:t>
                       </a:r>
                       <a:endParaRPr lang="en-US" sz="1050" dirty="0">
                         <a:latin typeface="Calibri" charset="0"/>
@@ -17008,7 +17056,7 @@
                           <a:ea typeface="Calibri" pitchFamily="34" charset="-122"/>
                           <a:cs typeface="Calibri" pitchFamily="34" charset="-120"/>
                         </a:rPr>
-                        <a:t>1 814,5</a:t>
+                        <a:t>1,814.5</a:t>
                       </a:r>
                       <a:endParaRPr lang="en-US" sz="1050" dirty="0">
                         <a:latin typeface="Calibri" charset="0"/>
@@ -17092,7 +17140,7 @@
                           <a:ea typeface="Calibri" pitchFamily="34" charset="-122"/>
                           <a:cs typeface="Calibri" pitchFamily="34" charset="-120"/>
                         </a:rPr>
-                        <a:t>1 804,2</a:t>
+                        <a:t>1,804.2</a:t>
                       </a:r>
                       <a:endParaRPr lang="en-US" sz="1050" dirty="0">
                         <a:latin typeface="Calibri" charset="0"/>
@@ -17133,7 +17181,7 @@
                           <a:ea typeface="Calibri" pitchFamily="34" charset="-122"/>
                           <a:cs typeface="Calibri" pitchFamily="34" charset="-120"/>
                         </a:rPr>
-                        <a:t>1 803,4</a:t>
+                        <a:t>1,803.4</a:t>
                       </a:r>
                       <a:endParaRPr lang="en-US" sz="1050" dirty="0">
                         <a:latin typeface="Calibri" charset="0"/>
@@ -17174,7 +17222,7 @@
                           <a:ea typeface="Calibri" pitchFamily="34" charset="-122"/>
                           <a:cs typeface="Calibri" pitchFamily="34" charset="-120"/>
                         </a:rPr>
-                        <a:t>1 804,5</a:t>
+                        <a:t>1,804.5</a:t>
                       </a:r>
                       <a:endParaRPr lang="en-US" sz="1050" dirty="0">
                         <a:latin typeface="Calibri" charset="0"/>
@@ -17215,7 +17263,7 @@
                           <a:ea typeface="Calibri" pitchFamily="34" charset="-122"/>
                           <a:cs typeface="Calibri" pitchFamily="34" charset="-120"/>
                         </a:rPr>
-                        <a:t>1 818,7</a:t>
+                        <a:t>1,818.7</a:t>
                       </a:r>
                       <a:endParaRPr lang="en-US" sz="1050" dirty="0">
                         <a:latin typeface="Calibri" charset="0"/>
@@ -17256,7 +17304,7 @@
                           <a:ea typeface="Calibri" pitchFamily="34" charset="-122"/>
                           <a:cs typeface="Calibri" pitchFamily="34" charset="-120"/>
                         </a:rPr>
-                        <a:t>1 814,8</a:t>
+                        <a:t>1,814.8</a:t>
                       </a:r>
                       <a:endParaRPr lang="en-US" sz="1050" dirty="0">
                         <a:latin typeface="Calibri" charset="0"/>
@@ -17297,7 +17345,7 @@
                           <a:ea typeface="Calibri" pitchFamily="34" charset="-122"/>
                           <a:cs typeface="Calibri" pitchFamily="34" charset="-120"/>
                         </a:rPr>
-                        <a:t>1 818,1</a:t>
+                        <a:t>1,818.1</a:t>
                       </a:r>
                       <a:endParaRPr lang="en-US" sz="1050" dirty="0">
                         <a:latin typeface="Calibri" charset="0"/>
@@ -17338,7 +17386,7 @@
                           <a:ea typeface="Calibri" pitchFamily="34" charset="-122"/>
                           <a:cs typeface="Calibri" pitchFamily="34" charset="-120"/>
                         </a:rPr>
-                        <a:t>1 816,9</a:t>
+                        <a:t>1,816.9</a:t>
                       </a:r>
                       <a:endParaRPr lang="en-US" sz="1050" dirty="0">
                         <a:latin typeface="Calibri" charset="0"/>
@@ -17379,7 +17427,7 @@
                           <a:ea typeface="Calibri" pitchFamily="34" charset="-122"/>
                           <a:cs typeface="Calibri" pitchFamily="34" charset="-120"/>
                         </a:rPr>
-                        <a:t>1 815,6</a:t>
+                        <a:t>1,815.6</a:t>
                       </a:r>
                       <a:endParaRPr lang="en-US" sz="1050" dirty="0">
                         <a:latin typeface="Calibri" charset="0"/>
@@ -17420,7 +17468,7 @@
                           <a:ea typeface="Calibri" pitchFamily="34" charset="-122"/>
                           <a:cs typeface="Calibri" pitchFamily="34" charset="-120"/>
                         </a:rPr>
-                        <a:t>1 815,7</a:t>
+                        <a:t>1,815.7</a:t>
                       </a:r>
                       <a:endParaRPr lang="en-US" sz="1050" dirty="0">
                         <a:latin typeface="Calibri" charset="0"/>
@@ -17461,7 +17509,7 @@
                           <a:ea typeface="Calibri" pitchFamily="34" charset="-122"/>
                           <a:cs typeface="Calibri" pitchFamily="34" charset="-120"/>
                         </a:rPr>
-                        <a:t>1 819,9</a:t>
+                        <a:t>1,819.9</a:t>
                       </a:r>
                       <a:endParaRPr lang="en-US" sz="1050" dirty="0">
                         <a:latin typeface="Calibri" charset="0"/>
@@ -17502,7 +17550,7 @@
                           <a:ea typeface="Calibri" pitchFamily="34" charset="-122"/>
                           <a:cs typeface="Calibri" pitchFamily="34" charset="-120"/>
                         </a:rPr>
-                        <a:t>1 818,6</a:t>
+                        <a:t>1,818.6</a:t>
                       </a:r>
                       <a:endParaRPr lang="en-US" sz="1050" dirty="0">
                         <a:latin typeface="Calibri" charset="0"/>
@@ -17543,7 +17591,7 @@
                           <a:ea typeface="Calibri" pitchFamily="34" charset="-122"/>
                           <a:cs typeface="Calibri" pitchFamily="34" charset="-120"/>
                         </a:rPr>
-                        <a:t>1 818,7</a:t>
+                        <a:t>1,818.7</a:t>
                       </a:r>
                       <a:endParaRPr lang="en-US" sz="1050" dirty="0">
                         <a:latin typeface="Calibri" charset="0"/>
@@ -17584,7 +17632,7 @@
                           <a:ea typeface="Calibri" pitchFamily="34" charset="-122"/>
                           <a:cs typeface="Calibri" pitchFamily="34" charset="-120"/>
                         </a:rPr>
-                        <a:t>1 818,5</a:t>
+                        <a:t>1,818.5</a:t>
                       </a:r>
                       <a:endParaRPr lang="en-US" sz="1050" dirty="0">
                         <a:latin typeface="Calibri" charset="0"/>
@@ -17668,7 +17716,7 @@
                           <a:ea typeface="Calibri" pitchFamily="34" charset="-122"/>
                           <a:cs typeface="Calibri" pitchFamily="34" charset="-120"/>
                         </a:rPr>
-                        <a:t>1 803,8</a:t>
+                        <a:t>1,803.8</a:t>
                       </a:r>
                       <a:endParaRPr lang="en-US" sz="1050" dirty="0">
                         <a:latin typeface="Calibri" charset="0"/>
@@ -17709,7 +17757,7 @@
                           <a:ea typeface="Calibri" pitchFamily="34" charset="-122"/>
                           <a:cs typeface="Calibri" pitchFamily="34" charset="-120"/>
                         </a:rPr>
-                        <a:t>1 802,8</a:t>
+                        <a:t>1,802.8</a:t>
                       </a:r>
                       <a:endParaRPr lang="en-US" sz="1050" dirty="0">
                         <a:latin typeface="Calibri" charset="0"/>
@@ -17750,7 +17798,7 @@
                           <a:ea typeface="Calibri" pitchFamily="34" charset="-122"/>
                           <a:cs typeface="Calibri" pitchFamily="34" charset="-120"/>
                         </a:rPr>
-                        <a:t>1 803,6</a:t>
+                        <a:t>1,803.6</a:t>
                       </a:r>
                       <a:endParaRPr lang="en-US" sz="1050" dirty="0">
                         <a:latin typeface="Calibri" charset="0"/>
@@ -17791,7 +17839,7 @@
                           <a:ea typeface="Calibri" pitchFamily="34" charset="-122"/>
                           <a:cs typeface="Calibri" pitchFamily="34" charset="-120"/>
                         </a:rPr>
-                        <a:t>1 817,4</a:t>
+                        <a:t>1,817.4</a:t>
                       </a:r>
                       <a:endParaRPr lang="en-US" sz="1050" dirty="0">
                         <a:latin typeface="Calibri" charset="0"/>
@@ -17832,7 +17880,7 @@
                           <a:ea typeface="Calibri" pitchFamily="34" charset="-122"/>
                           <a:cs typeface="Calibri" pitchFamily="34" charset="-120"/>
                         </a:rPr>
-                        <a:t>1 820,2</a:t>
+                        <a:t>1,820.2</a:t>
                       </a:r>
                       <a:endParaRPr lang="en-US" sz="1050" dirty="0">
                         <a:latin typeface="Calibri" charset="0"/>
@@ -17873,7 +17921,7 @@
                           <a:ea typeface="Calibri" pitchFamily="34" charset="-122"/>
                           <a:cs typeface="Calibri" pitchFamily="34" charset="-120"/>
                         </a:rPr>
-                        <a:t>1 817,6</a:t>
+                        <a:t>1,817.6</a:t>
                       </a:r>
                       <a:endParaRPr lang="en-US" sz="1050" dirty="0">
                         <a:latin typeface="Calibri" charset="0"/>
@@ -17914,7 +17962,7 @@
                           <a:ea typeface="Calibri" pitchFamily="34" charset="-122"/>
                           <a:cs typeface="Calibri" pitchFamily="34" charset="-120"/>
                         </a:rPr>
-                        <a:t>1 817,5</a:t>
+                        <a:t>1,817.5</a:t>
                       </a:r>
                       <a:endParaRPr lang="en-US" sz="1050" dirty="0">
                         <a:latin typeface="Calibri" charset="0"/>
@@ -17955,7 +18003,7 @@
                           <a:ea typeface="Calibri" pitchFamily="34" charset="-122"/>
                           <a:cs typeface="Calibri" pitchFamily="34" charset="-120"/>
                         </a:rPr>
-                        <a:t>1 815,4</a:t>
+                        <a:t>1,815.4</a:t>
                       </a:r>
                       <a:endParaRPr lang="en-US" sz="1050" dirty="0">
                         <a:latin typeface="Calibri" charset="0"/>
@@ -17996,7 +18044,7 @@
                           <a:ea typeface="Calibri" pitchFamily="34" charset="-122"/>
                           <a:cs typeface="Calibri" pitchFamily="34" charset="-120"/>
                         </a:rPr>
-                        <a:t>1 815,8</a:t>
+                        <a:t>1,815.8</a:t>
                       </a:r>
                       <a:endParaRPr lang="en-US" sz="1050" dirty="0">
                         <a:latin typeface="Calibri" charset="0"/>
@@ -18037,7 +18085,7 @@
                           <a:ea typeface="Calibri" pitchFamily="34" charset="-122"/>
                           <a:cs typeface="Calibri" pitchFamily="34" charset="-120"/>
                         </a:rPr>
-                        <a:t>1 819,9</a:t>
+                        <a:t>1,819.9</a:t>
                       </a:r>
                       <a:endParaRPr lang="en-US" sz="1050" dirty="0">
                         <a:latin typeface="Calibri" charset="0"/>
@@ -18078,7 +18126,7 @@
                           <a:ea typeface="Calibri" pitchFamily="34" charset="-122"/>
                           <a:cs typeface="Calibri" pitchFamily="34" charset="-120"/>
                         </a:rPr>
-                        <a:t>1 820,0</a:t>
+                        <a:t>1,820.0</a:t>
                       </a:r>
                       <a:endParaRPr lang="en-US" sz="1050" dirty="0">
                         <a:latin typeface="Calibri" charset="0"/>
@@ -18119,7 +18167,7 @@
                           <a:ea typeface="Calibri" pitchFamily="34" charset="-122"/>
                           <a:cs typeface="Calibri" pitchFamily="34" charset="-120"/>
                         </a:rPr>
-                        <a:t>1 819,9</a:t>
+                        <a:t>1,819.9</a:t>
                       </a:r>
                       <a:endParaRPr lang="en-US" sz="1050" dirty="0">
                         <a:latin typeface="Calibri" charset="0"/>
@@ -18160,7 +18208,7 @@
                           <a:ea typeface="Calibri" pitchFamily="34" charset="-122"/>
                           <a:cs typeface="Calibri" pitchFamily="34" charset="-120"/>
                         </a:rPr>
-                        <a:t>1 819,9</a:t>
+                        <a:t>1,819.9</a:t>
                       </a:r>
                       <a:endParaRPr lang="en-US" sz="1050" dirty="0">
                         <a:latin typeface="Calibri" charset="0"/>
@@ -18250,7 +18298,7 @@
                           <a:ea typeface="Calibri" pitchFamily="34" charset="-122"/>
                           <a:cs typeface="Calibri" pitchFamily="34" charset="-120"/>
                         </a:rPr>
-                        <a:t>1 803,2</a:t>
+                        <a:t>1,803.2</a:t>
                       </a:r>
                       <a:endParaRPr lang="en-US" sz="1050" dirty="0">
                         <a:latin typeface="Calibri" charset="0"/>
@@ -18297,7 +18345,7 @@
                           <a:ea typeface="Calibri" pitchFamily="34" charset="-122"/>
                           <a:cs typeface="Calibri" pitchFamily="34" charset="-120"/>
                         </a:rPr>
-                        <a:t>1 804,3</a:t>
+                        <a:t>1,804.3</a:t>
                       </a:r>
                       <a:endParaRPr lang="en-US" sz="1050" dirty="0">
                         <a:latin typeface="Calibri" charset="0"/>
@@ -18344,7 +18392,7 @@
                           <a:ea typeface="Calibri" pitchFamily="34" charset="-122"/>
                           <a:cs typeface="Calibri" pitchFamily="34" charset="-120"/>
                         </a:rPr>
-                        <a:t>1 804,4</a:t>
+                        <a:t>1,804.4</a:t>
                       </a:r>
                       <a:endParaRPr lang="en-US" sz="1050" dirty="0">
                         <a:latin typeface="Calibri" charset="0"/>
@@ -18391,7 +18439,7 @@
                           <a:ea typeface="Calibri" pitchFamily="34" charset="-122"/>
                           <a:cs typeface="Calibri" pitchFamily="34" charset="-120"/>
                         </a:rPr>
-                        <a:t>1 817,6</a:t>
+                        <a:t>1,817.6</a:t>
                       </a:r>
                       <a:endParaRPr lang="en-US" sz="1050" dirty="0">
                         <a:latin typeface="Calibri" charset="0"/>
@@ -18438,7 +18486,7 @@
                           <a:ea typeface="Calibri" pitchFamily="34" charset="-122"/>
                           <a:cs typeface="Calibri" pitchFamily="34" charset="-120"/>
                         </a:rPr>
-                        <a:t>1 816,3</a:t>
+                        <a:t>1,816.3</a:t>
                       </a:r>
                       <a:endParaRPr lang="en-US" sz="1050" dirty="0">
                         <a:latin typeface="Calibri" charset="0"/>
@@ -18485,7 +18533,7 @@
                           <a:ea typeface="Calibri" pitchFamily="34" charset="-122"/>
                           <a:cs typeface="Calibri" pitchFamily="34" charset="-120"/>
                         </a:rPr>
-                        <a:t>1 816,8</a:t>
+                        <a:t>1,816.8</a:t>
                       </a:r>
                       <a:endParaRPr lang="en-US" sz="1050" dirty="0">
                         <a:latin typeface="Calibri" charset="0"/>
@@ -18532,7 +18580,7 @@
                           <a:ea typeface="Calibri" pitchFamily="34" charset="-122"/>
                           <a:cs typeface="Calibri" pitchFamily="34" charset="-120"/>
                         </a:rPr>
-                        <a:t>1 816,5</a:t>
+                        <a:t>1,816.5</a:t>
                       </a:r>
                       <a:endParaRPr lang="en-US" sz="1050" dirty="0">
                         <a:latin typeface="Calibri" charset="0"/>
@@ -18579,7 +18627,7 @@
                           <a:ea typeface="Calibri" pitchFamily="34" charset="-122"/>
                           <a:cs typeface="Calibri" pitchFamily="34" charset="-120"/>
                         </a:rPr>
-                        <a:t>1 814,9</a:t>
+                        <a:t>1,814.9</a:t>
                       </a:r>
                       <a:endParaRPr lang="en-US" sz="1050" dirty="0">
                         <a:latin typeface="Calibri" charset="0"/>
@@ -18626,7 +18674,7 @@
                           <a:ea typeface="Calibri" pitchFamily="34" charset="-122"/>
                           <a:cs typeface="Calibri" pitchFamily="34" charset="-120"/>
                         </a:rPr>
-                        <a:t>1 815,9</a:t>
+                        <a:t>1,815.9</a:t>
                       </a:r>
                       <a:endParaRPr lang="en-US" sz="1050" dirty="0">
                         <a:latin typeface="Calibri" charset="0"/>
@@ -18673,7 +18721,7 @@
                           <a:ea typeface="Calibri" pitchFamily="34" charset="-122"/>
                           <a:cs typeface="Calibri" pitchFamily="34" charset="-120"/>
                         </a:rPr>
-                        <a:t>1 819,9</a:t>
+                        <a:t>1,819.9</a:t>
                       </a:r>
                       <a:endParaRPr lang="en-US" sz="1050" dirty="0">
                         <a:latin typeface="Calibri" charset="0"/>
@@ -18720,7 +18768,7 @@
                           <a:ea typeface="Calibri" pitchFamily="34" charset="-122"/>
                           <a:cs typeface="Calibri" pitchFamily="34" charset="-120"/>
                         </a:rPr>
-                        <a:t>1 819,9</a:t>
+                        <a:t>1,819.9</a:t>
                       </a:r>
                       <a:endParaRPr lang="en-US" sz="1050" dirty="0">
                         <a:latin typeface="Calibri" charset="0"/>
@@ -18767,7 +18815,7 @@
                           <a:ea typeface="Calibri" pitchFamily="34" charset="-122"/>
                           <a:cs typeface="Calibri" pitchFamily="34" charset="-120"/>
                         </a:rPr>
-                        <a:t>1 819,9</a:t>
+                        <a:t>1,819.9</a:t>
                       </a:r>
                       <a:endParaRPr lang="en-US" sz="1050" dirty="0">
                         <a:latin typeface="Calibri" charset="0"/>
@@ -18814,7 +18862,7 @@
                           <a:ea typeface="Calibri" pitchFamily="34" charset="-122"/>
                           <a:cs typeface="Calibri" pitchFamily="34" charset="-120"/>
                         </a:rPr>
-                        <a:t>1 819,9</a:t>
+                        <a:t>1,819.9</a:t>
                       </a:r>
                       <a:endParaRPr lang="en-US" sz="1050" dirty="0">
                         <a:latin typeface="Calibri" charset="0"/>
@@ -18904,7 +18952,7 @@
                           <a:ea typeface="Calibri" pitchFamily="34" charset="-122"/>
                           <a:cs typeface="Calibri" pitchFamily="34" charset="-120"/>
                         </a:rPr>
-                        <a:t>1 659,2</a:t>
+                        <a:t>1,659.2</a:t>
                       </a:r>
                       <a:endParaRPr lang="en-US" sz="1050" dirty="0">
                         <a:latin typeface="Calibri" charset="0"/>
@@ -18945,7 +18993,7 @@
                           <a:ea typeface="Calibri" pitchFamily="34" charset="-122"/>
                           <a:cs typeface="Calibri" pitchFamily="34" charset="-120"/>
                         </a:rPr>
-                        <a:t>1 663,1</a:t>
+                        <a:t>1,663.1</a:t>
                       </a:r>
                       <a:endParaRPr lang="en-US" sz="1050" dirty="0">
                         <a:latin typeface="Calibri" charset="0"/>
@@ -18986,7 +19034,7 @@
                           <a:ea typeface="Calibri" pitchFamily="34" charset="-122"/>
                           <a:cs typeface="Calibri" pitchFamily="34" charset="-120"/>
                         </a:rPr>
-                        <a:t>1 658,2</a:t>
+                        <a:t>1,658.2</a:t>
                       </a:r>
                       <a:endParaRPr lang="en-US" sz="1050" dirty="0">
                         <a:latin typeface="Calibri" charset="0"/>
@@ -19027,7 +19075,7 @@
                           <a:ea typeface="Calibri" pitchFamily="34" charset="-122"/>
                           <a:cs typeface="Calibri" pitchFamily="34" charset="-120"/>
                         </a:rPr>
-                        <a:t>1 674,3</a:t>
+                        <a:t>1,674.3</a:t>
                       </a:r>
                       <a:endParaRPr lang="en-US" sz="1050" dirty="0">
                         <a:latin typeface="Calibri" charset="0"/>
@@ -19068,7 +19116,7 @@
                           <a:ea typeface="Calibri" pitchFamily="34" charset="-122"/>
                           <a:cs typeface="Calibri" pitchFamily="34" charset="-120"/>
                         </a:rPr>
-                        <a:t>1 682,4</a:t>
+                        <a:t>1,682.4</a:t>
                       </a:r>
                       <a:endParaRPr lang="en-US" sz="1050" dirty="0">
                         <a:latin typeface="Calibri" charset="0"/>
@@ -19109,7 +19157,7 @@
                           <a:ea typeface="Calibri" pitchFamily="34" charset="-122"/>
                           <a:cs typeface="Calibri" pitchFamily="34" charset="-120"/>
                         </a:rPr>
-                        <a:t>1 602,1</a:t>
+                        <a:t>1,602.1</a:t>
                       </a:r>
                       <a:endParaRPr lang="en-US" sz="1050" dirty="0">
                         <a:latin typeface="Calibri" charset="0"/>
@@ -19150,7 +19198,7 @@
                           <a:ea typeface="Calibri" pitchFamily="34" charset="-122"/>
                           <a:cs typeface="Calibri" pitchFamily="34" charset="-120"/>
                         </a:rPr>
-                        <a:t>1 566,5</a:t>
+                        <a:t>1,566.5</a:t>
                       </a:r>
                       <a:endParaRPr lang="en-US" sz="1050" dirty="0">
                         <a:latin typeface="Calibri" charset="0"/>
@@ -19191,7 +19239,7 @@
                           <a:ea typeface="Calibri" pitchFamily="34" charset="-122"/>
                           <a:cs typeface="Calibri" pitchFamily="34" charset="-120"/>
                         </a:rPr>
-                        <a:t>1 544,8</a:t>
+                        <a:t>1,544.8</a:t>
                       </a:r>
                       <a:endParaRPr lang="en-US" sz="1050" dirty="0">
                         <a:latin typeface="Calibri" charset="0"/>
@@ -19232,7 +19280,7 @@
                           <a:ea typeface="Calibri" pitchFamily="34" charset="-122"/>
                           <a:cs typeface="Calibri" pitchFamily="34" charset="-120"/>
                         </a:rPr>
-                        <a:t>1 547,0</a:t>
+                        <a:t>1,547.0</a:t>
                       </a:r>
                       <a:endParaRPr lang="en-US" sz="1050" dirty="0">
                         <a:latin typeface="Calibri" charset="0"/>
@@ -19273,7 +19321,7 @@
                           <a:ea typeface="Calibri" pitchFamily="34" charset="-122"/>
                           <a:cs typeface="Calibri" pitchFamily="34" charset="-120"/>
                         </a:rPr>
-                        <a:t>1 615,2</a:t>
+                        <a:t>1,615.2</a:t>
                       </a:r>
                       <a:endParaRPr lang="en-US" sz="1050" dirty="0">
                         <a:latin typeface="Calibri" charset="0"/>
@@ -19314,7 +19362,7 @@
                           <a:ea typeface="Calibri" pitchFamily="34" charset="-122"/>
                           <a:cs typeface="Calibri" pitchFamily="34" charset="-120"/>
                         </a:rPr>
-                        <a:t>1 612,5</a:t>
+                        <a:t>1,612.5</a:t>
                       </a:r>
                       <a:endParaRPr lang="en-US" sz="1050" dirty="0">
                         <a:latin typeface="Calibri" charset="0"/>
@@ -19355,7 +19403,7 @@
                           <a:ea typeface="Calibri" pitchFamily="34" charset="-122"/>
                           <a:cs typeface="Calibri" pitchFamily="34" charset="-120"/>
                         </a:rPr>
-                        <a:t>1 608,5</a:t>
+                        <a:t>1,608.5</a:t>
                       </a:r>
                       <a:endParaRPr lang="en-US" sz="1050" dirty="0">
                         <a:latin typeface="Calibri" charset="0"/>
@@ -19396,7 +19444,7 @@
                           <a:ea typeface="Calibri" pitchFamily="34" charset="-122"/>
                           <a:cs typeface="Calibri" pitchFamily="34" charset="-120"/>
                         </a:rPr>
-                        <a:t>1 606,4</a:t>
+                        <a:t>1,606.4</a:t>
                       </a:r>
                       <a:endParaRPr lang="en-US" sz="1050" dirty="0">
                         <a:latin typeface="Calibri" charset="0"/>
@@ -19480,7 +19528,7 @@
                           <a:ea typeface="Calibri" pitchFamily="34" charset="-122"/>
                           <a:cs typeface="Calibri" pitchFamily="34" charset="-120"/>
                         </a:rPr>
-                        <a:t>1 585,5</a:t>
+                        <a:t>1,585.5</a:t>
                       </a:r>
                       <a:endParaRPr lang="en-US" sz="1050" dirty="0">
                         <a:latin typeface="Calibri" charset="0"/>
@@ -19521,7 +19569,7 @@
                           <a:ea typeface="Calibri" pitchFamily="34" charset="-122"/>
                           <a:cs typeface="Calibri" pitchFamily="34" charset="-120"/>
                         </a:rPr>
-                        <a:t>1 586,3</a:t>
+                        <a:t>1,586.3</a:t>
                       </a:r>
                       <a:endParaRPr lang="en-US" sz="1050" dirty="0">
                         <a:latin typeface="Calibri" charset="0"/>
@@ -19562,7 +19610,7 @@
                           <a:ea typeface="Calibri" pitchFamily="34" charset="-122"/>
                           <a:cs typeface="Calibri" pitchFamily="34" charset="-120"/>
                         </a:rPr>
-                        <a:t>1 584,1</a:t>
+                        <a:t>1,584.1</a:t>
                       </a:r>
                       <a:endParaRPr lang="en-US" sz="1050" dirty="0">
                         <a:latin typeface="Calibri" charset="0"/>
@@ -19603,7 +19651,7 @@
                           <a:ea typeface="Calibri" pitchFamily="34" charset="-122"/>
                           <a:cs typeface="Calibri" pitchFamily="34" charset="-120"/>
                         </a:rPr>
-                        <a:t>1 592,3</a:t>
+                        <a:t>1,592.3</a:t>
                       </a:r>
                       <a:endParaRPr lang="en-US" sz="1050" dirty="0">
                         <a:latin typeface="Calibri" charset="0"/>
@@ -19644,7 +19692,7 @@
                           <a:ea typeface="Calibri" pitchFamily="34" charset="-122"/>
                           <a:cs typeface="Calibri" pitchFamily="34" charset="-120"/>
                         </a:rPr>
-                        <a:t>1 588,4</a:t>
+                        <a:t>1,588.4</a:t>
                       </a:r>
                       <a:endParaRPr lang="en-US" sz="1050" dirty="0">
                         <a:latin typeface="Calibri" charset="0"/>
@@ -19685,7 +19733,7 @@
                           <a:ea typeface="Calibri" pitchFamily="34" charset="-122"/>
                           <a:cs typeface="Calibri" pitchFamily="34" charset="-120"/>
                         </a:rPr>
-                        <a:t>1 592,3</a:t>
+                        <a:t>1,592.3</a:t>
                       </a:r>
                       <a:endParaRPr lang="en-US" sz="1050" dirty="0">
                         <a:latin typeface="Calibri" charset="0"/>
@@ -19726,7 +19774,7 @@
                           <a:ea typeface="Calibri" pitchFamily="34" charset="-122"/>
                           <a:cs typeface="Calibri" pitchFamily="34" charset="-120"/>
                         </a:rPr>
-                        <a:t>1 470,1</a:t>
+                        <a:t>1,470.1</a:t>
                       </a:r>
                       <a:endParaRPr lang="en-US" sz="1050" dirty="0">
                         <a:latin typeface="Calibri" charset="0"/>
@@ -19767,7 +19815,7 @@
                           <a:ea typeface="Calibri" pitchFamily="34" charset="-122"/>
                           <a:cs typeface="Calibri" pitchFamily="34" charset="-120"/>
                         </a:rPr>
-                        <a:t>1 484,0</a:t>
+                        <a:t>1,484.0</a:t>
                       </a:r>
                       <a:endParaRPr lang="en-US" sz="1050" dirty="0">
                         <a:latin typeface="Calibri" charset="0"/>
@@ -19808,7 +19856,7 @@
                           <a:ea typeface="Calibri" pitchFamily="34" charset="-122"/>
                           <a:cs typeface="Calibri" pitchFamily="34" charset="-120"/>
                         </a:rPr>
-                        <a:t>1 482,6</a:t>
+                        <a:t>1,482.6</a:t>
                       </a:r>
                       <a:endParaRPr lang="en-US" sz="1050" dirty="0">
                         <a:latin typeface="Calibri" charset="0"/>
@@ -19849,7 +19897,7 @@
                           <a:ea typeface="Calibri" pitchFamily="34" charset="-122"/>
                           <a:cs typeface="Calibri" pitchFamily="34" charset="-120"/>
                         </a:rPr>
-                        <a:t>1 551,8</a:t>
+                        <a:t>1,551.8</a:t>
                       </a:r>
                       <a:endParaRPr lang="en-US" sz="1050" dirty="0">
                         <a:latin typeface="Calibri" charset="0"/>
@@ -19890,7 +19938,7 @@
                           <a:ea typeface="Calibri" pitchFamily="34" charset="-122"/>
                           <a:cs typeface="Calibri" pitchFamily="34" charset="-120"/>
                         </a:rPr>
-                        <a:t>1 550,8</a:t>
+                        <a:t>1,550.8</a:t>
                       </a:r>
                       <a:endParaRPr lang="en-US" sz="1050" dirty="0">
                         <a:latin typeface="Calibri" charset="0"/>
@@ -19931,7 +19979,7 @@
                           <a:ea typeface="Calibri" pitchFamily="34" charset="-122"/>
                           <a:cs typeface="Calibri" pitchFamily="34" charset="-120"/>
                         </a:rPr>
-                        <a:t>1 564,0</a:t>
+                        <a:t>1,564.0</a:t>
                       </a:r>
                       <a:endParaRPr lang="en-US" sz="1050" dirty="0">
                         <a:latin typeface="Calibri" charset="0"/>
@@ -19972,7 +20020,7 @@
                           <a:ea typeface="Calibri" pitchFamily="34" charset="-122"/>
                           <a:cs typeface="Calibri" pitchFamily="34" charset="-120"/>
                         </a:rPr>
-                        <a:t>1 554,1</a:t>
+                        <a:t>1,554.1</a:t>
                       </a:r>
                       <a:endParaRPr lang="en-US" sz="1050" dirty="0">
                         <a:latin typeface="Calibri" charset="0"/>
@@ -20062,7 +20110,7 @@
                           <a:ea typeface="Calibri" pitchFamily="34" charset="-122"/>
                           <a:cs typeface="Calibri" pitchFamily="34" charset="-120"/>
                         </a:rPr>
-                        <a:t>1 578,8</a:t>
+                        <a:t>1,578.8</a:t>
                       </a:r>
                       <a:endParaRPr lang="en-US" sz="1050" dirty="0">
                         <a:latin typeface="Calibri" charset="0"/>
@@ -20109,7 +20157,7 @@
                           <a:ea typeface="Calibri" pitchFamily="34" charset="-122"/>
                           <a:cs typeface="Calibri" pitchFamily="34" charset="-120"/>
                         </a:rPr>
-                        <a:t>1 581,8</a:t>
+                        <a:t>1,581.8</a:t>
                       </a:r>
                       <a:endParaRPr lang="en-US" sz="1050" dirty="0">
                         <a:latin typeface="Calibri" charset="0"/>
@@ -20156,7 +20204,7 @@
                           <a:ea typeface="Calibri" pitchFamily="34" charset="-122"/>
                           <a:cs typeface="Calibri" pitchFamily="34" charset="-120"/>
                         </a:rPr>
-                        <a:t>1 582,9</a:t>
+                        <a:t>1,582.9</a:t>
                       </a:r>
                       <a:endParaRPr lang="en-US" sz="1050" dirty="0">
                         <a:latin typeface="Calibri" charset="0"/>
@@ -20203,7 +20251,7 @@
                           <a:ea typeface="Calibri" pitchFamily="34" charset="-122"/>
                           <a:cs typeface="Calibri" pitchFamily="34" charset="-120"/>
                         </a:rPr>
-                        <a:t>1 554,9</a:t>
+                        <a:t>1,554.9</a:t>
                       </a:r>
                       <a:endParaRPr lang="en-US" sz="1050" dirty="0">
                         <a:latin typeface="Calibri" charset="0"/>
@@ -20250,7 +20298,7 @@
                           <a:ea typeface="Calibri" pitchFamily="34" charset="-122"/>
                           <a:cs typeface="Calibri" pitchFamily="34" charset="-120"/>
                         </a:rPr>
-                        <a:t>1 551,9</a:t>
+                        <a:t>1,551.9</a:t>
                       </a:r>
                       <a:endParaRPr lang="en-US" sz="1050" dirty="0">
                         <a:latin typeface="Calibri" charset="0"/>
@@ -20297,7 +20345,7 @@
                           <a:ea typeface="Calibri" pitchFamily="34" charset="-122"/>
                           <a:cs typeface="Calibri" pitchFamily="34" charset="-120"/>
                         </a:rPr>
-                        <a:t>1 597,5</a:t>
+                        <a:t>1,597.5</a:t>
                       </a:r>
                       <a:endParaRPr lang="en-US" sz="1050" dirty="0">
                         <a:latin typeface="Calibri" charset="0"/>
@@ -20344,7 +20392,7 @@
                           <a:ea typeface="Calibri" pitchFamily="34" charset="-122"/>
                           <a:cs typeface="Calibri" pitchFamily="34" charset="-120"/>
                         </a:rPr>
-                        <a:t>1 465,3</a:t>
+                        <a:t>1,465.3</a:t>
                       </a:r>
                       <a:endParaRPr lang="en-US" sz="1050" dirty="0">
                         <a:latin typeface="Calibri" charset="0"/>
@@ -20391,7 +20439,7 @@
                           <a:ea typeface="Calibri" pitchFamily="34" charset="-122"/>
                           <a:cs typeface="Calibri" pitchFamily="34" charset="-120"/>
                         </a:rPr>
-                        <a:t>1 473,4</a:t>
+                        <a:t>1,473.4</a:t>
                       </a:r>
                       <a:endParaRPr lang="en-US" sz="1050" dirty="0">
                         <a:latin typeface="Calibri" charset="0"/>
@@ -20438,7 +20486,7 @@
                           <a:ea typeface="Calibri" pitchFamily="34" charset="-122"/>
                           <a:cs typeface="Calibri" pitchFamily="34" charset="-120"/>
                         </a:rPr>
-                        <a:t>1 462,2</a:t>
+                        <a:t>1,462.2</a:t>
                       </a:r>
                       <a:endParaRPr lang="en-US" sz="1050" dirty="0">
                         <a:latin typeface="Calibri" charset="0"/>
@@ -20485,7 +20533,7 @@
                           <a:ea typeface="Calibri" pitchFamily="34" charset="-122"/>
                           <a:cs typeface="Calibri" pitchFamily="34" charset="-120"/>
                         </a:rPr>
-                        <a:t>1 562,1</a:t>
+                        <a:t>1,562.1</a:t>
                       </a:r>
                       <a:endParaRPr lang="en-US" sz="1050" dirty="0">
                         <a:latin typeface="Calibri" charset="0"/>
@@ -20532,7 +20580,7 @@
                           <a:ea typeface="Calibri" pitchFamily="34" charset="-122"/>
                           <a:cs typeface="Calibri" pitchFamily="34" charset="-120"/>
                         </a:rPr>
-                        <a:t>1 554,2</a:t>
+                        <a:t>1,554.2</a:t>
                       </a:r>
                       <a:endParaRPr lang="en-US" sz="1050" dirty="0">
                         <a:latin typeface="Calibri" charset="0"/>
@@ -20579,7 +20627,7 @@
                           <a:ea typeface="Calibri" pitchFamily="34" charset="-122"/>
                           <a:cs typeface="Calibri" pitchFamily="34" charset="-120"/>
                         </a:rPr>
-                        <a:t>1 551,6</a:t>
+                        <a:t>1,551.6</a:t>
                       </a:r>
                       <a:endParaRPr lang="en-US" sz="1050" dirty="0">
                         <a:latin typeface="Calibri" charset="0"/>
@@ -20626,7 +20674,7 @@
                           <a:ea typeface="Calibri" pitchFamily="34" charset="-122"/>
                           <a:cs typeface="Calibri" pitchFamily="34" charset="-120"/>
                         </a:rPr>
-                        <a:t>1 558,5</a:t>
+                        <a:t>1,558.5</a:t>
                       </a:r>
                       <a:endParaRPr lang="en-US" sz="1050" dirty="0">
                         <a:latin typeface="Calibri" charset="0"/>
@@ -20716,7 +20764,7 @@
                           <a:ea typeface="Calibri" pitchFamily="34" charset="-122"/>
                           <a:cs typeface="Calibri" pitchFamily="34" charset="-120"/>
                         </a:rPr>
-                        <a:t>5 329,4</a:t>
+                        <a:t>5,329.4</a:t>
                       </a:r>
                       <a:endParaRPr lang="en-US" sz="1050" dirty="0">
                         <a:latin typeface="Calibri" charset="0"/>
@@ -20757,7 +20805,7 @@
                           <a:ea typeface="Calibri" pitchFamily="34" charset="-122"/>
                           <a:cs typeface="Calibri" pitchFamily="34" charset="-120"/>
                         </a:rPr>
-                        <a:t>5 290,1</a:t>
+                        <a:t>5,290.1</a:t>
                       </a:r>
                       <a:endParaRPr lang="en-US" sz="1050" dirty="0">
                         <a:latin typeface="Calibri" charset="0"/>
@@ -20798,7 +20846,7 @@
                           <a:ea typeface="Calibri" pitchFamily="34" charset="-122"/>
                           <a:cs typeface="Calibri" pitchFamily="34" charset="-120"/>
                         </a:rPr>
-                        <a:t>5 262,1</a:t>
+                        <a:t>5,262.1</a:t>
                       </a:r>
                       <a:endParaRPr lang="en-US" sz="1050" dirty="0">
                         <a:latin typeface="Calibri" charset="0"/>
@@ -20839,7 +20887,7 @@
                           <a:ea typeface="Calibri" pitchFamily="34" charset="-122"/>
                           <a:cs typeface="Calibri" pitchFamily="34" charset="-120"/>
                         </a:rPr>
-                        <a:t>4 829,5</a:t>
+                        <a:t>4,829.5</a:t>
                       </a:r>
                       <a:endParaRPr lang="en-US" sz="1050" dirty="0">
                         <a:latin typeface="Calibri" charset="0"/>
@@ -20880,7 +20928,7 @@
                           <a:ea typeface="Calibri" pitchFamily="34" charset="-122"/>
                           <a:cs typeface="Calibri" pitchFamily="34" charset="-120"/>
                         </a:rPr>
-                        <a:t>4 836,8</a:t>
+                        <a:t>4,836.8</a:t>
                       </a:r>
                       <a:endParaRPr lang="en-US" sz="1050" dirty="0">
                         <a:latin typeface="Calibri" charset="0"/>
@@ -20921,7 +20969,7 @@
                           <a:ea typeface="Calibri" pitchFamily="34" charset="-122"/>
                           <a:cs typeface="Calibri" pitchFamily="34" charset="-120"/>
                         </a:rPr>
-                        <a:t>4 834,2</a:t>
+                        <a:t>4,834.2</a:t>
                       </a:r>
                       <a:endParaRPr lang="en-US" sz="1050" dirty="0">
                         <a:latin typeface="Calibri" charset="0"/>
@@ -21085,7 +21133,7 @@
                           <a:ea typeface="Calibri" pitchFamily="34" charset="-122"/>
                           <a:cs typeface="Calibri" pitchFamily="34" charset="-120"/>
                         </a:rPr>
-                        <a:t>4 796,8</a:t>
+                        <a:t>4,796.8</a:t>
                       </a:r>
                       <a:endParaRPr lang="en-US" sz="1050" dirty="0">
                         <a:latin typeface="Calibri" charset="0"/>
@@ -21126,7 +21174,7 @@
                           <a:ea typeface="Calibri" pitchFamily="34" charset="-122"/>
                           <a:cs typeface="Calibri" pitchFamily="34" charset="-120"/>
                         </a:rPr>
-                        <a:t>4 800,4</a:t>
+                        <a:t>4,800.4</a:t>
                       </a:r>
                       <a:endParaRPr lang="en-US" sz="1050" dirty="0">
                         <a:latin typeface="Calibri" charset="0"/>
@@ -21167,7 +21215,7 @@
                           <a:ea typeface="Calibri" pitchFamily="34" charset="-122"/>
                           <a:cs typeface="Calibri" pitchFamily="34" charset="-120"/>
                         </a:rPr>
-                        <a:t>4 804,4</a:t>
+                        <a:t>4,804.4</a:t>
                       </a:r>
                       <a:endParaRPr lang="en-US" sz="1050" dirty="0">
                         <a:latin typeface="Calibri" charset="0"/>
@@ -21208,7 +21256,7 @@
                           <a:ea typeface="Calibri" pitchFamily="34" charset="-122"/>
                           <a:cs typeface="Calibri" pitchFamily="34" charset="-120"/>
                         </a:rPr>
-                        <a:t>4 793,7</a:t>
+                        <a:t>4,793.7</a:t>
                       </a:r>
                       <a:endParaRPr lang="en-US" sz="1050" dirty="0">
                         <a:latin typeface="Calibri" charset="0"/>
@@ -21292,7 +21340,7 @@
                           <a:ea typeface="Calibri" pitchFamily="34" charset="-122"/>
                           <a:cs typeface="Calibri" pitchFamily="34" charset="-120"/>
                         </a:rPr>
-                        <a:t>5 167,2</a:t>
+                        <a:t>5,167.2</a:t>
                       </a:r>
                       <a:endParaRPr lang="en-US" sz="1050" dirty="0">
                         <a:latin typeface="Calibri" charset="0"/>
@@ -21333,7 +21381,7 @@
                           <a:ea typeface="Calibri" pitchFamily="34" charset="-122"/>
                           <a:cs typeface="Calibri" pitchFamily="34" charset="-120"/>
                         </a:rPr>
-                        <a:t>5 056,0</a:t>
+                        <a:t>5,056.0</a:t>
                       </a:r>
                       <a:endParaRPr lang="en-US" sz="1050" dirty="0">
                         <a:latin typeface="Calibri" charset="0"/>
@@ -21374,7 +21422,7 @@
                           <a:ea typeface="Calibri" pitchFamily="34" charset="-122"/>
                           <a:cs typeface="Calibri" pitchFamily="34" charset="-120"/>
                         </a:rPr>
-                        <a:t>5 031,7</a:t>
+                        <a:t>5,031.7</a:t>
                       </a:r>
                       <a:endParaRPr lang="en-US" sz="1050" dirty="0">
                         <a:latin typeface="Calibri" charset="0"/>
@@ -21415,7 +21463,7 @@
                           <a:ea typeface="Calibri" pitchFamily="34" charset="-122"/>
                           <a:cs typeface="Calibri" pitchFamily="34" charset="-120"/>
                         </a:rPr>
-                        <a:t>4 795,8</a:t>
+                        <a:t>4,795.8</a:t>
                       </a:r>
                       <a:endParaRPr lang="en-US" sz="1050" dirty="0">
                         <a:latin typeface="Calibri" charset="0"/>
@@ -21456,7 +21504,7 @@
                           <a:ea typeface="Calibri" pitchFamily="34" charset="-122"/>
                           <a:cs typeface="Calibri" pitchFamily="34" charset="-120"/>
                         </a:rPr>
-                        <a:t>4 796,2</a:t>
+                        <a:t>4,796.2</a:t>
                       </a:r>
                       <a:endParaRPr lang="en-US" sz="1050" dirty="0">
                         <a:latin typeface="Calibri" charset="0"/>
@@ -21497,7 +21545,7 @@
                           <a:ea typeface="Calibri" pitchFamily="34" charset="-122"/>
                           <a:cs typeface="Calibri" pitchFamily="34" charset="-120"/>
                         </a:rPr>
-                        <a:t>4 797,9</a:t>
+                        <a:t>4,797.9</a:t>
                       </a:r>
                       <a:endParaRPr lang="en-US" sz="1050" dirty="0">
                         <a:latin typeface="Calibri" charset="0"/>
@@ -21661,7 +21709,7 @@
                           <a:ea typeface="Calibri" pitchFamily="34" charset="-122"/>
                           <a:cs typeface="Calibri" pitchFamily="34" charset="-120"/>
                         </a:rPr>
-                        <a:t>4 795,5</a:t>
+                        <a:t>4,795.5</a:t>
                       </a:r>
                       <a:endParaRPr lang="en-US" sz="1050" dirty="0">
                         <a:latin typeface="Calibri" charset="0"/>
@@ -21702,7 +21750,7 @@
                           <a:ea typeface="Calibri" pitchFamily="34" charset="-122"/>
                           <a:cs typeface="Calibri" pitchFamily="34" charset="-120"/>
                         </a:rPr>
-                        <a:t>4 795,4</a:t>
+                        <a:t>4,795.4</a:t>
                       </a:r>
                       <a:endParaRPr lang="en-US" sz="1050" dirty="0">
                         <a:latin typeface="Calibri" charset="0"/>
@@ -21743,7 +21791,7 @@
                           <a:ea typeface="Calibri" pitchFamily="34" charset="-122"/>
                           <a:cs typeface="Calibri" pitchFamily="34" charset="-120"/>
                         </a:rPr>
-                        <a:t>4 795,6</a:t>
+                        <a:t>4,795.6</a:t>
                       </a:r>
                       <a:endParaRPr lang="en-US" sz="1050" dirty="0">
                         <a:latin typeface="Calibri" charset="0"/>
@@ -21784,7 +21832,7 @@
                           <a:ea typeface="Calibri" pitchFamily="34" charset="-122"/>
                           <a:cs typeface="Calibri" pitchFamily="34" charset="-120"/>
                         </a:rPr>
-                        <a:t>4 793,7</a:t>
+                        <a:t>4,793.7</a:t>
                       </a:r>
                       <a:endParaRPr lang="en-US" sz="1050" dirty="0">
                         <a:latin typeface="Calibri" charset="0"/>
@@ -21874,7 +21922,7 @@
                           <a:ea typeface="Calibri" pitchFamily="34" charset="-122"/>
                           <a:cs typeface="Calibri" pitchFamily="34" charset="-120"/>
                         </a:rPr>
-                        <a:t>4 930,1</a:t>
+                        <a:t>4,930.1</a:t>
                       </a:r>
                       <a:endParaRPr lang="en-US" sz="1050" dirty="0">
                         <a:latin typeface="Calibri" charset="0"/>
@@ -21921,7 +21969,7 @@
                           <a:ea typeface="Calibri" pitchFamily="34" charset="-122"/>
                           <a:cs typeface="Calibri" pitchFamily="34" charset="-120"/>
                         </a:rPr>
-                        <a:t>4 921,6</a:t>
+                        <a:t>4,921.6</a:t>
                       </a:r>
                       <a:endParaRPr lang="en-US" sz="1050" dirty="0">
                         <a:latin typeface="Calibri" charset="0"/>
@@ -21968,7 +22016,7 @@
                           <a:ea typeface="Calibri" pitchFamily="34" charset="-122"/>
                           <a:cs typeface="Calibri" pitchFamily="34" charset="-120"/>
                         </a:rPr>
-                        <a:t>5 203,6</a:t>
+                        <a:t>5,203.6</a:t>
                       </a:r>
                       <a:endParaRPr lang="en-US" sz="1050" dirty="0">
                         <a:latin typeface="Calibri" charset="0"/>
@@ -22015,7 +22063,7 @@
                           <a:ea typeface="Calibri" pitchFamily="34" charset="-122"/>
                           <a:cs typeface="Calibri" pitchFamily="34" charset="-120"/>
                         </a:rPr>
-                        <a:t>4 794,4</a:t>
+                        <a:t>4,794.4</a:t>
                       </a:r>
                       <a:endParaRPr lang="en-US" sz="1050" dirty="0">
                         <a:latin typeface="Calibri" charset="0"/>
@@ -22062,7 +22110,7 @@
                           <a:ea typeface="Calibri" pitchFamily="34" charset="-122"/>
                           <a:cs typeface="Calibri" pitchFamily="34" charset="-120"/>
                         </a:rPr>
-                        <a:t>4 795,6</a:t>
+                        <a:t>4,795.6</a:t>
                       </a:r>
                       <a:endParaRPr lang="en-US" sz="1050" dirty="0">
                         <a:latin typeface="Calibri" charset="0"/>
@@ -22109,7 +22157,7 @@
                           <a:ea typeface="Calibri" pitchFamily="34" charset="-122"/>
                           <a:cs typeface="Calibri" pitchFamily="34" charset="-120"/>
                         </a:rPr>
-                        <a:t>4 800,0</a:t>
+                        <a:t>4,800.0</a:t>
                       </a:r>
                       <a:endParaRPr lang="en-US" sz="1050" dirty="0">
                         <a:latin typeface="Calibri" charset="0"/>
@@ -22297,7 +22345,7 @@
                           <a:ea typeface="Calibri" pitchFamily="34" charset="-122"/>
                           <a:cs typeface="Calibri" pitchFamily="34" charset="-120"/>
                         </a:rPr>
-                        <a:t>4 795,4</a:t>
+                        <a:t>4,795.4</a:t>
                       </a:r>
                       <a:endParaRPr lang="en-US" sz="1050" dirty="0">
                         <a:latin typeface="Calibri" charset="0"/>
@@ -22344,7 +22392,7 @@
                           <a:ea typeface="Calibri" pitchFamily="34" charset="-122"/>
                           <a:cs typeface="Calibri" pitchFamily="34" charset="-120"/>
                         </a:rPr>
-                        <a:t>4 795,3</a:t>
+                        <a:t>4,795.3</a:t>
                       </a:r>
                       <a:endParaRPr lang="en-US" sz="1050" dirty="0">
                         <a:latin typeface="Calibri" charset="0"/>
@@ -22391,7 +22439,7 @@
                           <a:ea typeface="Calibri" pitchFamily="34" charset="-122"/>
                           <a:cs typeface="Calibri" pitchFamily="34" charset="-120"/>
                         </a:rPr>
-                        <a:t>4 795,3</a:t>
+                        <a:t>4,795.3</a:t>
                       </a:r>
                       <a:endParaRPr lang="en-US" sz="1050" dirty="0">
                         <a:latin typeface="Calibri" charset="0"/>
@@ -22438,7 +22486,7 @@
                           <a:ea typeface="Calibri" pitchFamily="34" charset="-122"/>
                           <a:cs typeface="Calibri" pitchFamily="34" charset="-120"/>
                         </a:rPr>
-                        <a:t>4 793,7</a:t>
+                        <a:t>4,793.7</a:t>
                       </a:r>
                       <a:endParaRPr lang="en-US" sz="1050" dirty="0">
                         <a:latin typeface="Calibri" charset="0"/>
@@ -22506,7 +22554,7 @@
                 <a:ea typeface="Calibri" pitchFamily="34" charset="-122"/>
                 <a:cs typeface="Calibri" pitchFamily="34" charset="-120"/>
               </a:rPr>
-              <a:t>Hipervolum ×1 000, çdo ekzekutim. Me të trasha: vlera më e mirë nga 3 që shfaqet në tabelë. — asnjë pikë e lejuar. Burimi: harness/benchmark-*.csv.</a:t>
+              <a:t>Hipervolum ×1,000, çdo ekzekutim. Me të trasha: vlera më e mirë nga 3 që shfaqet në tabelë. — asnjë pikë e lejuar. Burimi: harness/benchmark-*.csv.</a:t>
             </a:r>
             <a:endParaRPr lang="en-US" sz="1050" dirty="0"/>
           </a:p>
@@ -22896,7 +22944,7 @@
                 <a:ea typeface="Calibri" pitchFamily="34" charset="-122"/>
                 <a:cs typeface="Calibri" pitchFamily="34" charset="-120"/>
               </a:rPr>
-              <a:t> = 0 e ndërtimit, me gjerësi 20, mbart 99,99% të rezultatit të tij; në medium-graph, me gjerësi 277, mbart 97,7%.</a:t>
+              <a:t> = 0 e ndërtimit, me gjerësi 20, mbart 99.99% të rezultatit të tij; në medium-graph, me gjerësi 277, mbart 97.7%.</a:t>
             </a:r>
             <a:endParaRPr lang="en-US" sz="1400" dirty="0"/>
           </a:p>
@@ -22991,7 +23039,7 @@
                 <a:ea typeface="Calibri" pitchFamily="34" charset="-122"/>
                 <a:cs typeface="Calibri" pitchFamily="34" charset="-120"/>
               </a:rPr>
-              <a:t>, 79,4% të katrorit, ndërsa më i miri i njohur arrin 93,3%: vetëm në familjen e dendur shkallarja e meriton vendin e vet.</a:t>
+              <a:t>, 79.4% të katrorit, ndërsa më i miri i njohur arrin 93.3%: vetëm në familjen e dendur shkallarja e meriton vendin e vet.</a:t>
             </a:r>
             <a:endParaRPr lang="en-US" sz="1400" dirty="0"/>
           </a:p>
@@ -23086,7 +23134,7 @@
                 <a:ea typeface="Calibri" pitchFamily="34" charset="-122"/>
                 <a:cs typeface="Calibri" pitchFamily="34" charset="-120"/>
               </a:rPr>
-              <a:t> = 1 357, </a:t>
+              <a:t> = 1,357, </a:t>
             </a:r>
             <a:pPr indent="0" marL="0">
               <a:buNone/>
@@ -23236,7 +23284,7 @@
                 <a:ea typeface="Century Schoolbook" pitchFamily="34" charset="-122"/>
                 <a:cs typeface="Century Schoolbook" pitchFamily="34" charset="-120"/>
               </a:rPr>
-              <a:t>98,5%</a:t>
+              <a:t>98.5%</a:t>
             </a:r>
             <a:endParaRPr lang="en-US" sz="2400" dirty="0"/>
           </a:p>
@@ -23275,7 +23323,7 @@
                 <a:ea typeface="Calibri" pitchFamily="34" charset="-122"/>
                 <a:cs typeface="Calibri" pitchFamily="34" charset="-120"/>
               </a:rPr>
-              <a:t>w = 20 nga n = 1 357 · 99,99% e rezultatit</a:t>
+              <a:t>w = 20 nga n = 1,357 · 99.99% e rezultatit</a:t>
             </a:r>
             <a:endParaRPr lang="en-US" sz="1050" dirty="0"/>
           </a:p>
@@ -23397,7 +23445,7 @@
                 <a:ea typeface="Century Schoolbook" pitchFamily="34" charset="-122"/>
                 <a:cs typeface="Century Schoolbook" pitchFamily="34" charset="-120"/>
               </a:rPr>
-              <a:t>79,4%</a:t>
+              <a:t>79.4%</a:t>
             </a:r>
             <a:endParaRPr lang="en-US" sz="2400" dirty="0"/>
           </a:p>
@@ -23436,7 +23484,7 @@
                 <a:ea typeface="Calibri" pitchFamily="34" charset="-122"/>
                 <a:cs typeface="Calibri" pitchFamily="34" charset="-120"/>
               </a:rPr>
-              <a:t>w ≥ 499 nga n = 2 426 · më i miri i njohur 93,3%</a:t>
+              <a:t>w ≥ 499 nga n = 2,426 · më i miri i njohur 93.3%</a:t>
             </a:r>
             <a:endParaRPr lang="en-US" sz="1050" dirty="0"/>
           </a:p>
@@ -25257,7 +25305,7 @@
                 <a:ea typeface="Century Schoolbook" pitchFamily="34" charset="-122"/>
                 <a:cs typeface="Century Schoolbook" pitchFamily="34" charset="-120"/>
               </a:rPr>
-              <a:t>1,8×</a:t>
+              <a:t>1.81×</a:t>
             </a:r>
             <a:endParaRPr lang="en-US" sz="2600" dirty="0"/>
           </a:p>
@@ -25296,7 +25344,7 @@
                 <a:ea typeface="Calibri" pitchFamily="34" charset="-122"/>
                 <a:cs typeface="Calibri" pitchFamily="34" charset="-120"/>
               </a:rPr>
-              <a:t>më shumë kandidatë në të njëjtën kohë reale, mesatare gjeometrike mbi dhjetë instanca (nga 1,6× te të rrallat deri në 1,9× te të dendurat)</a:t>
+              <a:t>më shumë kandidatë në të njëjtën kohë reale, mesatare gjeometrike mbi dhjetë instanca (nga 1.7× te të rrallat deri në 1.9× te të dendurat)</a:t>
             </a:r>
             <a:endParaRPr lang="en-US" sz="1150" dirty="0"/>
           </a:p>
@@ -25355,7 +25403,7 @@
                 <a:ea typeface="Calibri" pitchFamily="34" charset="-122"/>
                 <a:cs typeface="Calibri" pitchFamily="34" charset="-120"/>
               </a:rPr>
-              <a:t>Pse lëvizjet e pranuara thuajse nuk kanë rëndësi: çdo kandidat i vlerësuar dhuron tërë shkallaren e vet në një front të përbashkët. Në synth-7 të katër operatorët origjinalë nuk pranuan asgjë fare, dhe rezultatet e tyre prapë ndryshojnë me 1 841 HV.</a:t>
+              <a:t>Pse lëvizjet e pranuara thuajse nuk kanë rëndësi: çdo kandidat i vlerësuar dhuron tërë shkallaren e vet në një front të përbashkët. Në synth-7 të katër operatorët origjinalë nuk pranuan asgjë fare, dhe rezultatet e tyre prapë ndryshojnë me 1,841 HV.</a:t>
             </a:r>
             <a:endParaRPr lang="en-US" sz="1300" dirty="0"/>
           </a:p>
@@ -25617,7 +25665,7 @@
                           <a:ea typeface="Calibri" pitchFamily="34" charset="-122"/>
                           <a:cs typeface="Calibri" pitchFamily="34" charset="-120"/>
                         </a:rPr>
-                        <a:t>1 200 s</a:t>
+                        <a:t>1,200 s</a:t>
                       </a:r>
                       <a:endParaRPr lang="en-US" sz="1100" dirty="0">
                         <a:latin typeface="Calibri" charset="0"/>
@@ -25670,7 +25718,7 @@
                           <a:ea typeface="Calibri" pitchFamily="34" charset="-122"/>
                           <a:cs typeface="Calibri" pitchFamily="34" charset="-120"/>
                         </a:rPr>
-                        <a:t>3 600 s</a:t>
+                        <a:t>3,600 s</a:t>
                       </a:r>
                       <a:endParaRPr lang="en-US" sz="1100" dirty="0">
                         <a:latin typeface="Calibri" charset="0"/>
@@ -25723,7 +25771,7 @@
                           <a:ea typeface="Calibri" pitchFamily="34" charset="-122"/>
                           <a:cs typeface="Calibri" pitchFamily="34" charset="-120"/>
                         </a:rPr>
-                        <a:t>12 000 s</a:t>
+                        <a:t>12,000 s</a:t>
                       </a:r>
                       <a:endParaRPr lang="en-US" sz="1100" dirty="0">
                         <a:latin typeface="Calibri" charset="0"/>
@@ -25925,7 +25973,7 @@
                           <a:ea typeface="Calibri" pitchFamily="34" charset="-122"/>
                           <a:cs typeface="Calibri" pitchFamily="34" charset="-120"/>
                         </a:rPr>
-                        <a:t>26 781 700</a:t>
+                        <a:t>26,781,700</a:t>
                       </a:r>
                       <a:endParaRPr lang="en-US" sz="1300" dirty="0">
                         <a:latin typeface="Calibri" charset="0"/>
@@ -25966,7 +26014,7 @@
                           <a:ea typeface="Calibri" pitchFamily="34" charset="-122"/>
                           <a:cs typeface="Calibri" pitchFamily="34" charset="-120"/>
                         </a:rPr>
-                        <a:t>26 762 079</a:t>
+                        <a:t>26,762,079</a:t>
                       </a:r>
                       <a:endParaRPr lang="en-US" sz="1300" dirty="0">
                         <a:latin typeface="Calibri" charset="0"/>
@@ -26007,7 +26055,7 @@
                           <a:ea typeface="Calibri" pitchFamily="34" charset="-122"/>
                           <a:cs typeface="Calibri" pitchFamily="34" charset="-120"/>
                         </a:rPr>
-                        <a:t>26 692 166</a:t>
+                        <a:t>26,692,166</a:t>
                       </a:r>
                       <a:endParaRPr lang="en-US" sz="1300" dirty="0">
                         <a:latin typeface="Calibri" charset="0"/>
@@ -26048,7 +26096,7 @@
                           <a:ea typeface="Calibri" pitchFamily="34" charset="-122"/>
                           <a:cs typeface="Calibri" pitchFamily="34" charset="-120"/>
                         </a:rPr>
-                        <a:t>−89 534</a:t>
+                        <a:t>−89,534</a:t>
                       </a:r>
                       <a:endParaRPr lang="en-US" sz="1300" dirty="0">
                         <a:latin typeface="Calibri" charset="0"/>
@@ -26173,7 +26221,7 @@
                           <a:ea typeface="Calibri" pitchFamily="34" charset="-122"/>
                           <a:cs typeface="Calibri" pitchFamily="34" charset="-120"/>
                         </a:rPr>
-                        <a:t>26 389 516</a:t>
+                        <a:t>26,389,516</a:t>
                       </a:r>
                       <a:endParaRPr lang="en-US" sz="1300" dirty="0">
                         <a:latin typeface="Calibri" charset="0"/>
@@ -26214,7 +26262,7 @@
                           <a:ea typeface="Calibri" pitchFamily="34" charset="-122"/>
                           <a:cs typeface="Calibri" pitchFamily="34" charset="-120"/>
                         </a:rPr>
-                        <a:t>26 404 696</a:t>
+                        <a:t>26,404,696</a:t>
                       </a:r>
                       <a:endParaRPr lang="en-US" sz="1300" dirty="0">
                         <a:latin typeface="Calibri" charset="0"/>
@@ -26255,7 +26303,7 @@
                           <a:ea typeface="Calibri" pitchFamily="34" charset="-122"/>
                           <a:cs typeface="Calibri" pitchFamily="34" charset="-120"/>
                         </a:rPr>
-                        <a:t>26 422 559</a:t>
+                        <a:t>26,422,559</a:t>
                       </a:r>
                       <a:endParaRPr lang="en-US" sz="1300" dirty="0">
                         <a:latin typeface="Calibri" charset="0"/>
@@ -26296,7 +26344,7 @@
                           <a:ea typeface="Calibri" pitchFamily="34" charset="-122"/>
                           <a:cs typeface="Calibri" pitchFamily="34" charset="-120"/>
                         </a:rPr>
-                        <a:t>+33 043</a:t>
+                        <a:t>+33,043</a:t>
                       </a:r>
                       <a:endParaRPr lang="en-US" sz="1300" dirty="0">
                         <a:latin typeface="Calibri" charset="0"/>
@@ -26421,7 +26469,7 @@
                           <a:ea typeface="Calibri" pitchFamily="34" charset="-122"/>
                           <a:cs typeface="Calibri" pitchFamily="34" charset="-120"/>
                         </a:rPr>
-                        <a:t>26 391 399</a:t>
+                        <a:t>26,391,399</a:t>
                       </a:r>
                       <a:endParaRPr lang="en-US" sz="1300" dirty="0">
                         <a:latin typeface="Calibri" charset="0"/>
@@ -26462,7 +26510,7 @@
                           <a:ea typeface="Calibri" pitchFamily="34" charset="-122"/>
                           <a:cs typeface="Calibri" pitchFamily="34" charset="-120"/>
                         </a:rPr>
-                        <a:t>26 393 577</a:t>
+                        <a:t>26,393,577</a:t>
                       </a:r>
                       <a:endParaRPr lang="en-US" sz="1300" dirty="0">
                         <a:latin typeface="Calibri" charset="0"/>
@@ -26503,7 +26551,7 @@
                           <a:ea typeface="Calibri" pitchFamily="34" charset="-122"/>
                           <a:cs typeface="Calibri" pitchFamily="34" charset="-120"/>
                         </a:rPr>
-                        <a:t>26 396 957</a:t>
+                        <a:t>26,396,957</a:t>
                       </a:r>
                       <a:endParaRPr lang="en-US" sz="1300" dirty="0">
                         <a:latin typeface="Calibri" charset="0"/>
@@ -26544,7 +26592,7 @@
                           <a:ea typeface="Calibri" pitchFamily="34" charset="-122"/>
                           <a:cs typeface="Calibri" pitchFamily="34" charset="-120"/>
                         </a:rPr>
-                        <a:t>+5 558</a:t>
+                        <a:t>+5,558</a:t>
                       </a:r>
                       <a:endParaRPr lang="en-US" sz="1300" dirty="0">
                         <a:latin typeface="Calibri" charset="0"/>
@@ -26675,7 +26723,7 @@
                           <a:ea typeface="Calibri" pitchFamily="34" charset="-122"/>
                           <a:cs typeface="Calibri" pitchFamily="34" charset="-120"/>
                         </a:rPr>
-                        <a:t>26 392 654</a:t>
+                        <a:t>26,392,654</a:t>
                       </a:r>
                       <a:endParaRPr lang="en-US" sz="1300" dirty="0">
                         <a:latin typeface="Calibri" charset="0"/>
@@ -26722,7 +26770,7 @@
                           <a:ea typeface="Calibri" pitchFamily="34" charset="-122"/>
                           <a:cs typeface="Calibri" pitchFamily="34" charset="-120"/>
                         </a:rPr>
-                        <a:t>26 388 897</a:t>
+                        <a:t>26,388,897</a:t>
                       </a:r>
                       <a:endParaRPr lang="en-US" sz="1300" dirty="0">
                         <a:latin typeface="Calibri" charset="0"/>
@@ -26769,7 +26817,7 @@
                           <a:ea typeface="Calibri" pitchFamily="34" charset="-122"/>
                           <a:cs typeface="Calibri" pitchFamily="34" charset="-120"/>
                         </a:rPr>
-                        <a:t>26 401 668</a:t>
+                        <a:t>26,401,668</a:t>
                       </a:r>
                       <a:endParaRPr lang="en-US" sz="1300" dirty="0">
                         <a:latin typeface="Calibri" charset="0"/>
@@ -26816,7 +26864,7 @@
                           <a:ea typeface="Calibri" pitchFamily="34" charset="-122"/>
                           <a:cs typeface="Calibri" pitchFamily="34" charset="-120"/>
                         </a:rPr>
-                        <a:t>+9 014</a:t>
+                        <a:t>+9,014</a:t>
                       </a:r>
                       <a:endParaRPr lang="en-US" sz="1300" dirty="0">
                         <a:latin typeface="Calibri" charset="0"/>
@@ -26970,7 +27018,7 @@
                 <a:ea typeface="Calibri" pitchFamily="34" charset="-122"/>
                 <a:cs typeface="Calibri" pitchFamily="34" charset="-120"/>
               </a:rPr>
-              <a:t>Varianti i ndërtimit merr një mostër tjetër ndërtimesh në çdo buxhet, prandaj totali i tij lëviz me 89 534 HV, dhe me një mostër për buxhet kjo lëvizje nuk mund të lexohet si prirje. Një lexim i mëhershëm e numëroi këtë lëvizje si kërkim që mbyll hendekun („31% e mbyllur”, një kryqëzim „rreth tridhjetë herë buxheti, rreth dhjetë orë”) dhe tërhiqet: 89 534 nga 122 577 HV që i quante mbyllje ishin mostra e ndërtimit.</a:t>
+              <a:t>Varianti i ndërtimit merr një mostër tjetër ndërtimesh në çdo buxhet, prandaj totali i tij lëviz me 89,534 HV, dhe me një mostër për buxhet kjo lëvizje nuk mund të lexohet si prirje. Një lexim i mëhershëm e numëroi këtë lëvizje si kërkim që mbyll hendekun („31% e mbyllur”, një kryqëzim „rreth tridhjetë herë buxheti, rreth dhjetë orë”) dhe tërhiqet: 89,534 nga 122,577 HV që i quante mbyllje ishin mostra e ndërtimit.</a:t>
             </a:r>
             <a:endParaRPr lang="en-US" sz="1350" dirty="0"/>
           </a:p>
@@ -32468,7 +32516,7 @@
                           <a:ea typeface="Calibri" pitchFamily="34" charset="-122"/>
                           <a:cs typeface="Calibri" pitchFamily="34" charset="-120"/>
                         </a:rPr>
-                        <a:t>1 357</a:t>
+                        <a:t>1,357</a:t>
                       </a:r>
                       <a:endParaRPr lang="en-US" sz="1300" dirty="0">
                         <a:latin typeface="Calibri" charset="0"/>
@@ -32562,7 +32610,7 @@
                           <a:ea typeface="Calibri" pitchFamily="34" charset="-122"/>
                           <a:cs typeface="Calibri" pitchFamily="34" charset="-120"/>
                         </a:rPr>
-                        <a:t>1 841 434</a:t>
+                        <a:t>1,841,434</a:t>
                       </a:r>
                       <a:endParaRPr lang="en-US" sz="1300" dirty="0">
                         <a:latin typeface="Calibri" charset="0"/>
@@ -32609,7 +32657,7 @@
                           <a:ea typeface="Calibri" pitchFamily="34" charset="-122"/>
                           <a:cs typeface="Calibri" pitchFamily="34" charset="-120"/>
                         </a:rPr>
-                        <a:t>1 829 919</a:t>
+                        <a:t>1,829,919</a:t>
                       </a:r>
                       <a:endParaRPr lang="en-US" sz="1300" dirty="0">
                         <a:latin typeface="Calibri" charset="0"/>
@@ -32656,7 +32704,7 @@
                           <a:ea typeface="Calibri" pitchFamily="34" charset="-122"/>
                           <a:cs typeface="Calibri" pitchFamily="34" charset="-120"/>
                         </a:rPr>
-                        <a:t>0,63%</a:t>
+                        <a:t>0.63%</a:t>
                       </a:r>
                       <a:endParaRPr lang="en-US" sz="1300" dirty="0">
                         <a:latin typeface="Calibri" charset="0"/>
@@ -32752,7 +32800,7 @@
                           <a:ea typeface="Calibri" pitchFamily="34" charset="-122"/>
                           <a:cs typeface="Calibri" pitchFamily="34" charset="-120"/>
                         </a:rPr>
-                        <a:t>1 399</a:t>
+                        <a:t>1,399</a:t>
                       </a:r>
                       <a:endParaRPr lang="en-US" sz="1300" dirty="0">
                         <a:latin typeface="Calibri" charset="0"/>
@@ -32846,7 +32894,7 @@
                           <a:ea typeface="Calibri" pitchFamily="34" charset="-122"/>
                           <a:cs typeface="Calibri" pitchFamily="34" charset="-120"/>
                         </a:rPr>
-                        <a:t>1 955 110</a:t>
+                        <a:t>1,955,110</a:t>
                       </a:r>
                       <a:endParaRPr lang="en-US" sz="1300" dirty="0">
                         <a:latin typeface="Calibri" charset="0"/>
@@ -32893,7 +32941,7 @@
                           <a:ea typeface="Calibri" pitchFamily="34" charset="-122"/>
                           <a:cs typeface="Calibri" pitchFamily="34" charset="-120"/>
                         </a:rPr>
-                        <a:t>1 745 122</a:t>
+                        <a:t>1,745,122</a:t>
                       </a:r>
                       <a:endParaRPr lang="en-US" sz="1300" dirty="0">
                         <a:latin typeface="Calibri" charset="0"/>
@@ -32940,7 +32988,7 @@
                           <a:ea typeface="Calibri" pitchFamily="34" charset="-122"/>
                           <a:cs typeface="Calibri" pitchFamily="34" charset="-120"/>
                         </a:rPr>
-                        <a:t>10,74%</a:t>
+                        <a:t>10.74%</a:t>
                       </a:r>
                       <a:endParaRPr lang="en-US" sz="1300" dirty="0">
                         <a:latin typeface="Calibri" charset="0"/>
@@ -33036,7 +33084,7 @@
                           <a:ea typeface="Calibri" pitchFamily="34" charset="-122"/>
                           <a:cs typeface="Calibri" pitchFamily="34" charset="-120"/>
                         </a:rPr>
-                        <a:t>2 426</a:t>
+                        <a:t>2,426</a:t>
                       </a:r>
                       <a:endParaRPr lang="en-US" sz="1300" dirty="0">
                         <a:latin typeface="Calibri" charset="0"/>
@@ -33130,7 +33178,7 @@
                           <a:ea typeface="Calibri" pitchFamily="34" charset="-122"/>
                           <a:cs typeface="Calibri" pitchFamily="34" charset="-120"/>
                         </a:rPr>
-                        <a:t>5 754 421</a:t>
+                        <a:t>5,754,421</a:t>
                       </a:r>
                       <a:endParaRPr lang="en-US" sz="1300" dirty="0">
                         <a:latin typeface="Calibri" charset="0"/>
@@ -33177,7 +33225,7 @@
                           <a:ea typeface="Calibri" pitchFamily="34" charset="-122"/>
                           <a:cs typeface="Calibri" pitchFamily="34" charset="-120"/>
                         </a:rPr>
-                        <a:t>5 493 062</a:t>
+                        <a:t>5,493,062</a:t>
                       </a:r>
                       <a:endParaRPr lang="en-US" sz="1300" dirty="0">
                         <a:latin typeface="Calibri" charset="0"/>
@@ -33224,7 +33272,7 @@
                           <a:ea typeface="Calibri" pitchFamily="34" charset="-122"/>
                           <a:cs typeface="Calibri" pitchFamily="34" charset="-120"/>
                         </a:rPr>
-                        <a:t>4,54%</a:t>
+                        <a:t>4.54%</a:t>
                       </a:r>
                       <a:endParaRPr lang="en-US" sz="1300" dirty="0">
                         <a:latin typeface="Calibri" charset="0"/>
@@ -33331,7 +33379,7 @@
                 <a:ea typeface="Calibri" pitchFamily="34" charset="-122"/>
                 <a:cs typeface="Calibri" pitchFamily="34" charset="-120"/>
               </a:rPr>
-              <a:t>brenda 0,63% të tavanit: praktikisht të zgjidhura</a:t>
+              <a:t>brenda 0.63% të tavanit: praktikisht të zgjidhura</a:t>
             </a:r>
             <a:endParaRPr lang="en-US" sz="1300" dirty="0"/>
           </a:p>
@@ -33409,7 +33457,7 @@
                 <a:ea typeface="Calibri" pitchFamily="34" charset="-122"/>
                 <a:cs typeface="Calibri" pitchFamily="34" charset="-120"/>
               </a:rPr>
-              <a:t>10,74%, kryesisht kufi i lirshëm: tw ≥ 63 heq vetëm 2 091 nga n² = 1 957 201</a:t>
+              <a:t>10.74%, kryesisht kufi i lirshëm: tw ≥ 63 heq vetëm 2,091 nga n² = 1,957,201</a:t>
             </a:r>
             <a:endParaRPr lang="en-US" sz="1300" dirty="0"/>
           </a:p>
@@ -33487,7 +33535,7 @@
                 <a:ea typeface="Calibri" pitchFamily="34" charset="-122"/>
                 <a:cs typeface="Calibri" pitchFamily="34" charset="-120"/>
               </a:rPr>
-              <a:t>një klikë me 500 kulme e ngulit tw në 499–500, pra 4,54% është hapësirë reale</a:t>
+              <a:t>një klikë me 500 kulme e ngulit tw në 499–500, pra 4.54% është hapësirë reale</a:t>
             </a:r>
             <a:endParaRPr lang="en-US" sz="1300" dirty="0"/>
           </a:p>
@@ -38046,7 +38094,7 @@
                 <a:ea typeface="Calibri" pitchFamily="34" charset="-122"/>
                 <a:cs typeface="Calibri" pitchFamily="34" charset="-120"/>
               </a:rPr>
-              <a:t>n = 1 357 · 2 280–2 282 brinjë · tw ≥ 5</a:t>
+              <a:t>n = 1,357 · 2,280–2,282 brinjë · tw ≥ 5</a:t>
             </a:r>
             <a:endParaRPr lang="en-US" sz="1250" dirty="0"/>
           </a:p>
@@ -38163,7 +38211,7 @@
                 <a:ea typeface="Calibri" pitchFamily="34" charset="-122"/>
                 <a:cs typeface="Calibri" pitchFamily="34" charset="-120"/>
               </a:rPr>
-              <a:t>n = 1 399 · 13 799 brinjë · tw ≥ 63–73</a:t>
+              <a:t>n = 1,399 · 13,799 brinjë · tw ≥ 63–73</a:t>
             </a:r>
             <a:endParaRPr lang="en-US" sz="1250" dirty="0"/>
           </a:p>
@@ -38280,7 +38328,7 @@
                 <a:ea typeface="Calibri" pitchFamily="34" charset="-122"/>
                 <a:cs typeface="Calibri" pitchFamily="34" charset="-120"/>
               </a:rPr>
-              <a:t>n = 2 426 · 253 895 brinjë · tw 499–500</a:t>
+              <a:t>n = 2,426 · 253,895 brinjë · tw 499–500</a:t>
             </a:r>
             <a:endParaRPr lang="en-US" sz="1250" dirty="0"/>
           </a:p>
@@ -39212,7 +39260,7 @@
                           <a:ea typeface="Calibri" pitchFamily="34" charset="-122"/>
                           <a:cs typeface="Calibri" pitchFamily="34" charset="-120"/>
                         </a:rPr>
-                        <a:t>1 808,0</a:t>
+                        <a:t>1,808.0</a:t>
                       </a:r>
                       <a:endParaRPr lang="en-US" sz="1250" dirty="0">
                         <a:latin typeface="Calibri" charset="0"/>
@@ -39253,7 +39301,7 @@
                           <a:ea typeface="Calibri" pitchFamily="34" charset="-122"/>
                           <a:cs typeface="Calibri" pitchFamily="34" charset="-120"/>
                         </a:rPr>
-                        <a:t>1 820,9</a:t>
+                        <a:t>1,820.9</a:t>
                       </a:r>
                       <a:endParaRPr lang="en-US" sz="1250" dirty="0">
                         <a:latin typeface="Calibri" charset="0"/>
@@ -39294,7 +39342,7 @@
                           <a:ea typeface="Calibri" pitchFamily="34" charset="-122"/>
                           <a:cs typeface="Calibri" pitchFamily="34" charset="-120"/>
                         </a:rPr>
-                        <a:t>1 827,5</a:t>
+                        <a:t>1,827.5</a:t>
                       </a:r>
                       <a:endParaRPr lang="en-US" sz="1250" dirty="0">
                         <a:latin typeface="Calibri" charset="0"/>
@@ -39340,7 +39388,7 @@
                           <a:ea typeface="Calibri" pitchFamily="34" charset="-122"/>
                           <a:cs typeface="Calibri" pitchFamily="34" charset="-120"/>
                         </a:rPr>
-                        <a:t>1 815,4</a:t>
+                        <a:t>1,815.4</a:t>
                       </a:r>
                       <a:endParaRPr lang="en-US" sz="1250" dirty="0">
                         <a:latin typeface="Calibri" charset="0"/>
@@ -39381,7 +39429,7 @@
                           <a:ea typeface="Calibri" pitchFamily="34" charset="-122"/>
                           <a:cs typeface="Calibri" pitchFamily="34" charset="-120"/>
                         </a:rPr>
-                        <a:t>1 814,5</a:t>
+                        <a:t>1,814.5</a:t>
                       </a:r>
                       <a:endParaRPr lang="en-US" sz="1250" dirty="0">
                         <a:latin typeface="Calibri" charset="0"/>
@@ -39465,7 +39513,7 @@
                           <a:ea typeface="Calibri" pitchFamily="34" charset="-122"/>
                           <a:cs typeface="Calibri" pitchFamily="34" charset="-120"/>
                         </a:rPr>
-                        <a:t>1 804,5</a:t>
+                        <a:t>1,804.5</a:t>
                       </a:r>
                       <a:endParaRPr lang="en-US" sz="1250" dirty="0">
                         <a:latin typeface="Calibri" charset="0"/>
@@ -39506,7 +39554,7 @@
                           <a:ea typeface="Calibri" pitchFamily="34" charset="-122"/>
                           <a:cs typeface="Calibri" pitchFamily="34" charset="-120"/>
                         </a:rPr>
-                        <a:t>1 818,7</a:t>
+                        <a:t>1,818.7</a:t>
                       </a:r>
                       <a:endParaRPr lang="en-US" sz="1250" dirty="0">
                         <a:latin typeface="Calibri" charset="0"/>
@@ -39547,7 +39595,7 @@
                           <a:ea typeface="Calibri" pitchFamily="34" charset="-122"/>
                           <a:cs typeface="Calibri" pitchFamily="34" charset="-120"/>
                         </a:rPr>
-                        <a:t>1 816,9</a:t>
+                        <a:t>1,816.9</a:t>
                       </a:r>
                       <a:endParaRPr lang="en-US" sz="1250" dirty="0">
                         <a:latin typeface="Calibri" charset="0"/>
@@ -39588,7 +39636,7 @@
                           <a:ea typeface="Calibri" pitchFamily="34" charset="-122"/>
                           <a:cs typeface="Calibri" pitchFamily="34" charset="-120"/>
                         </a:rPr>
-                        <a:t>1 819,9</a:t>
+                        <a:t>1,819.9</a:t>
                       </a:r>
                       <a:endParaRPr lang="en-US" sz="1250" dirty="0">
                         <a:latin typeface="Calibri" charset="0"/>
@@ -39634,7 +39682,7 @@
                           <a:ea typeface="Calibri" pitchFamily="34" charset="-122"/>
                           <a:cs typeface="Calibri" pitchFamily="34" charset="-120"/>
                         </a:rPr>
-                        <a:t>1 818,5</a:t>
+                        <a:t>1,818.5</a:t>
                       </a:r>
                       <a:endParaRPr lang="en-US" sz="1250" dirty="0">
                         <a:latin typeface="Calibri" charset="0"/>
@@ -39718,7 +39766,7 @@
                           <a:ea typeface="Calibri" pitchFamily="34" charset="-122"/>
                           <a:cs typeface="Calibri" pitchFamily="34" charset="-120"/>
                         </a:rPr>
-                        <a:t>1 803,8</a:t>
+                        <a:t>1,803.8</a:t>
                       </a:r>
                       <a:endParaRPr lang="en-US" sz="1250" dirty="0">
                         <a:latin typeface="Calibri" charset="0"/>
@@ -39759,7 +39807,7 @@
                           <a:ea typeface="Calibri" pitchFamily="34" charset="-122"/>
                           <a:cs typeface="Calibri" pitchFamily="34" charset="-120"/>
                         </a:rPr>
-                        <a:t>1 820,2</a:t>
+                        <a:t>1,820.2</a:t>
                       </a:r>
                       <a:endParaRPr lang="en-US" sz="1250" dirty="0">
                         <a:latin typeface="Calibri" charset="0"/>
@@ -39805,7 +39853,7 @@
                           <a:ea typeface="Calibri" pitchFamily="34" charset="-122"/>
                           <a:cs typeface="Calibri" pitchFamily="34" charset="-120"/>
                         </a:rPr>
-                        <a:t>1 817,5</a:t>
+                        <a:t>1,817.5</a:t>
                       </a:r>
                       <a:endParaRPr lang="en-US" sz="1250" dirty="0">
                         <a:latin typeface="Calibri" charset="0"/>
@@ -39846,7 +39894,7 @@
                           <a:ea typeface="Calibri" pitchFamily="34" charset="-122"/>
                           <a:cs typeface="Calibri" pitchFamily="34" charset="-120"/>
                         </a:rPr>
-                        <a:t>1 820,0</a:t>
+                        <a:t>1,820.0</a:t>
                       </a:r>
                       <a:endParaRPr lang="en-US" sz="1250" dirty="0">
                         <a:latin typeface="Calibri" charset="0"/>
@@ -39887,7 +39935,7 @@
                           <a:ea typeface="Calibri" pitchFamily="34" charset="-122"/>
                           <a:cs typeface="Calibri" pitchFamily="34" charset="-120"/>
                         </a:rPr>
-                        <a:t>1 819,9</a:t>
+                        <a:t>1,819.9</a:t>
                       </a:r>
                       <a:endParaRPr lang="en-US" sz="1250" dirty="0">
                         <a:latin typeface="Calibri" charset="0"/>
@@ -39971,7 +40019,7 @@
                           <a:ea typeface="Calibri" pitchFamily="34" charset="-122"/>
                           <a:cs typeface="Calibri" pitchFamily="34" charset="-120"/>
                         </a:rPr>
-                        <a:t>1 804,4</a:t>
+                        <a:t>1,804.4</a:t>
                       </a:r>
                       <a:endParaRPr lang="en-US" sz="1250" dirty="0">
                         <a:latin typeface="Calibri" charset="0"/>
@@ -40012,7 +40060,7 @@
                           <a:ea typeface="Calibri" pitchFamily="34" charset="-122"/>
                           <a:cs typeface="Calibri" pitchFamily="34" charset="-120"/>
                         </a:rPr>
-                        <a:t>1 817,6</a:t>
+                        <a:t>1,817.6</a:t>
                       </a:r>
                       <a:endParaRPr lang="en-US" sz="1250" dirty="0">
                         <a:latin typeface="Calibri" charset="0"/>
@@ -40053,7 +40101,7 @@
                           <a:ea typeface="Calibri" pitchFamily="34" charset="-122"/>
                           <a:cs typeface="Calibri" pitchFamily="34" charset="-120"/>
                         </a:rPr>
-                        <a:t>1 816,5</a:t>
+                        <a:t>1,816.5</a:t>
                       </a:r>
                       <a:endParaRPr lang="en-US" sz="1250" dirty="0">
                         <a:latin typeface="Calibri" charset="0"/>
@@ -40094,7 +40142,7 @@
                           <a:ea typeface="Calibri" pitchFamily="34" charset="-122"/>
                           <a:cs typeface="Calibri" pitchFamily="34" charset="-120"/>
                         </a:rPr>
-                        <a:t>1 819,9</a:t>
+                        <a:t>1,819.9</a:t>
                       </a:r>
                       <a:endParaRPr lang="en-US" sz="1250" dirty="0">
                         <a:latin typeface="Calibri" charset="0"/>
@@ -40140,7 +40188,7 @@
                           <a:ea typeface="Calibri" pitchFamily="34" charset="-122"/>
                           <a:cs typeface="Calibri" pitchFamily="34" charset="-120"/>
                         </a:rPr>
-                        <a:t>1 819,9</a:t>
+                        <a:t>1,819.9</a:t>
                       </a:r>
                       <a:endParaRPr lang="en-US" sz="1250" dirty="0">
                         <a:latin typeface="Calibri" charset="0"/>
@@ -40282,7 +40330,7 @@
                           <a:ea typeface="Calibri" pitchFamily="34" charset="-122"/>
                           <a:cs typeface="Calibri" pitchFamily="34" charset="-120"/>
                         </a:rPr>
-                        <a:t>1 663,1</a:t>
+                        <a:t>1,663.1</a:t>
                       </a:r>
                       <a:endParaRPr lang="en-US" sz="1250" dirty="0">
                         <a:latin typeface="Calibri" charset="0"/>
@@ -40323,7 +40371,7 @@
                           <a:ea typeface="Calibri" pitchFamily="34" charset="-122"/>
                           <a:cs typeface="Calibri" pitchFamily="34" charset="-120"/>
                         </a:rPr>
-                        <a:t>1 682,4</a:t>
+                        <a:t>1,682.4</a:t>
                       </a:r>
                       <a:endParaRPr lang="en-US" sz="1250" dirty="0">
                         <a:latin typeface="Calibri" charset="0"/>
@@ -40369,7 +40417,7 @@
                           <a:ea typeface="Calibri" pitchFamily="34" charset="-122"/>
                           <a:cs typeface="Calibri" pitchFamily="34" charset="-120"/>
                         </a:rPr>
-                        <a:t>1 566,5</a:t>
+                        <a:t>1,566.5</a:t>
                       </a:r>
                       <a:endParaRPr lang="en-US" sz="1250" dirty="0">
                         <a:latin typeface="Calibri" charset="0"/>
@@ -40410,7 +40458,7 @@
                           <a:ea typeface="Calibri" pitchFamily="34" charset="-122"/>
                           <a:cs typeface="Calibri" pitchFamily="34" charset="-120"/>
                         </a:rPr>
-                        <a:t>1 615,2</a:t>
+                        <a:t>1,615.2</a:t>
                       </a:r>
                       <a:endParaRPr lang="en-US" sz="1250" dirty="0">
                         <a:latin typeface="Calibri" charset="0"/>
@@ -40451,7 +40499,7 @@
                           <a:ea typeface="Calibri" pitchFamily="34" charset="-122"/>
                           <a:cs typeface="Calibri" pitchFamily="34" charset="-120"/>
                         </a:rPr>
-                        <a:t>1 606,4</a:t>
+                        <a:t>1,606.4</a:t>
                       </a:r>
                       <a:endParaRPr lang="en-US" sz="1250" dirty="0">
                         <a:latin typeface="Calibri" charset="0"/>
@@ -40535,7 +40583,7 @@
                           <a:ea typeface="Calibri" pitchFamily="34" charset="-122"/>
                           <a:cs typeface="Calibri" pitchFamily="34" charset="-120"/>
                         </a:rPr>
-                        <a:t>1 586,3</a:t>
+                        <a:t>1,586.3</a:t>
                       </a:r>
                       <a:endParaRPr lang="en-US" sz="1250" dirty="0">
                         <a:latin typeface="Calibri" charset="0"/>
@@ -40576,7 +40624,7 @@
                           <a:ea typeface="Calibri" pitchFamily="34" charset="-122"/>
                           <a:cs typeface="Calibri" pitchFamily="34" charset="-120"/>
                         </a:rPr>
-                        <a:t>1 592,3</a:t>
+                        <a:t>1,592.3</a:t>
                       </a:r>
                       <a:endParaRPr lang="en-US" sz="1250" dirty="0">
                         <a:latin typeface="Calibri" charset="0"/>
@@ -40622,7 +40670,7 @@
                           <a:ea typeface="Calibri" pitchFamily="34" charset="-122"/>
                           <a:cs typeface="Calibri" pitchFamily="34" charset="-120"/>
                         </a:rPr>
-                        <a:t>1 484,0</a:t>
+                        <a:t>1,484.0</a:t>
                       </a:r>
                       <a:endParaRPr lang="en-US" sz="1250" dirty="0">
                         <a:latin typeface="Calibri" charset="0"/>
@@ -40663,7 +40711,7 @@
                           <a:ea typeface="Calibri" pitchFamily="34" charset="-122"/>
                           <a:cs typeface="Calibri" pitchFamily="34" charset="-120"/>
                         </a:rPr>
-                        <a:t>1 564,0</a:t>
+                        <a:t>1,564.0</a:t>
                       </a:r>
                       <a:endParaRPr lang="en-US" sz="1250" dirty="0">
                         <a:latin typeface="Calibri" charset="0"/>
@@ -40704,7 +40752,7 @@
                           <a:ea typeface="Calibri" pitchFamily="34" charset="-122"/>
                           <a:cs typeface="Calibri" pitchFamily="34" charset="-120"/>
                         </a:rPr>
-                        <a:t>1 554,1</a:t>
+                        <a:t>1,554.1</a:t>
                       </a:r>
                       <a:endParaRPr lang="en-US" sz="1250" dirty="0">
                         <a:latin typeface="Calibri" charset="0"/>
@@ -40788,7 +40836,7 @@
                           <a:ea typeface="Calibri" pitchFamily="34" charset="-122"/>
                           <a:cs typeface="Calibri" pitchFamily="34" charset="-120"/>
                         </a:rPr>
-                        <a:t>1 582,9</a:t>
+                        <a:t>1,582.9</a:t>
                       </a:r>
                       <a:endParaRPr lang="en-US" sz="1250" dirty="0">
                         <a:latin typeface="Calibri" charset="0"/>
@@ -40829,7 +40877,7 @@
                           <a:ea typeface="Calibri" pitchFamily="34" charset="-122"/>
                           <a:cs typeface="Calibri" pitchFamily="34" charset="-120"/>
                         </a:rPr>
-                        <a:t>1 597,5</a:t>
+                        <a:t>1,597.5</a:t>
                       </a:r>
                       <a:endParaRPr lang="en-US" sz="1250" dirty="0">
                         <a:latin typeface="Calibri" charset="0"/>
@@ -40875,7 +40923,7 @@
                           <a:ea typeface="Calibri" pitchFamily="34" charset="-122"/>
                           <a:cs typeface="Calibri" pitchFamily="34" charset="-120"/>
                         </a:rPr>
-                        <a:t>1 473,4</a:t>
+                        <a:t>1,473.4</a:t>
                       </a:r>
                       <a:endParaRPr lang="en-US" sz="1250" dirty="0">
                         <a:latin typeface="Calibri" charset="0"/>
@@ -40916,7 +40964,7 @@
                           <a:ea typeface="Calibri" pitchFamily="34" charset="-122"/>
                           <a:cs typeface="Calibri" pitchFamily="34" charset="-120"/>
                         </a:rPr>
-                        <a:t>1 562,1</a:t>
+                        <a:t>1,562.1</a:t>
                       </a:r>
                       <a:endParaRPr lang="en-US" sz="1250" dirty="0">
                         <a:latin typeface="Calibri" charset="0"/>
@@ -40957,7 +41005,7 @@
                           <a:ea typeface="Calibri" pitchFamily="34" charset="-122"/>
                           <a:cs typeface="Calibri" pitchFamily="34" charset="-120"/>
                         </a:rPr>
-                        <a:t>1 558,5</a:t>
+                        <a:t>1,558.5</a:t>
                       </a:r>
                       <a:endParaRPr lang="en-US" sz="1250" dirty="0">
                         <a:latin typeface="Calibri" charset="0"/>
@@ -41099,7 +41147,7 @@
                           <a:ea typeface="Calibri" pitchFamily="34" charset="-122"/>
                           <a:cs typeface="Calibri" pitchFamily="34" charset="-120"/>
                         </a:rPr>
-                        <a:t>5 329,4</a:t>
+                        <a:t>5,329.4</a:t>
                       </a:r>
                       <a:endParaRPr lang="en-US" sz="1250" dirty="0">
                         <a:latin typeface="Calibri" charset="0"/>
@@ -41145,7 +41193,7 @@
                           <a:ea typeface="Calibri" pitchFamily="34" charset="-122"/>
                           <a:cs typeface="Calibri" pitchFamily="34" charset="-120"/>
                         </a:rPr>
-                        <a:t>4 836,8</a:t>
+                        <a:t>4,836.8</a:t>
                       </a:r>
                       <a:endParaRPr lang="en-US" sz="1250" dirty="0">
                         <a:latin typeface="Calibri" charset="0"/>
@@ -41227,7 +41275,7 @@
                           <a:ea typeface="Calibri" pitchFamily="34" charset="-122"/>
                           <a:cs typeface="Calibri" pitchFamily="34" charset="-120"/>
                         </a:rPr>
-                        <a:t>4 804,4</a:t>
+                        <a:t>4,804.4</a:t>
                       </a:r>
                       <a:endParaRPr lang="en-US" sz="1250" dirty="0">
                         <a:latin typeface="Calibri" charset="0"/>
@@ -41268,7 +41316,7 @@
                           <a:ea typeface="Calibri" pitchFamily="34" charset="-122"/>
                           <a:cs typeface="Calibri" pitchFamily="34" charset="-120"/>
                         </a:rPr>
-                        <a:t>4 793,7</a:t>
+                        <a:t>4,793.7</a:t>
                       </a:r>
                       <a:endParaRPr lang="en-US" sz="1250" dirty="0">
                         <a:latin typeface="Calibri" charset="0"/>
@@ -41352,7 +41400,7 @@
                           <a:ea typeface="Calibri" pitchFamily="34" charset="-122"/>
                           <a:cs typeface="Calibri" pitchFamily="34" charset="-120"/>
                         </a:rPr>
-                        <a:t>5 167,2</a:t>
+                        <a:t>5,167.2</a:t>
                       </a:r>
                       <a:endParaRPr lang="en-US" sz="1250" dirty="0">
                         <a:latin typeface="Calibri" charset="0"/>
@@ -41398,7 +41446,7 @@
                           <a:ea typeface="Calibri" pitchFamily="34" charset="-122"/>
                           <a:cs typeface="Calibri" pitchFamily="34" charset="-120"/>
                         </a:rPr>
-                        <a:t>4 797,9</a:t>
+                        <a:t>4,797.9</a:t>
                       </a:r>
                       <a:endParaRPr lang="en-US" sz="1250" dirty="0">
                         <a:latin typeface="Calibri" charset="0"/>
@@ -41480,7 +41528,7 @@
                           <a:ea typeface="Calibri" pitchFamily="34" charset="-122"/>
                           <a:cs typeface="Calibri" pitchFamily="34" charset="-120"/>
                         </a:rPr>
-                        <a:t>4 795,6</a:t>
+                        <a:t>4,795.6</a:t>
                       </a:r>
                       <a:endParaRPr lang="en-US" sz="1250" dirty="0">
                         <a:latin typeface="Calibri" charset="0"/>
@@ -41521,7 +41569,7 @@
                           <a:ea typeface="Calibri" pitchFamily="34" charset="-122"/>
                           <a:cs typeface="Calibri" pitchFamily="34" charset="-120"/>
                         </a:rPr>
-                        <a:t>4 793,7</a:t>
+                        <a:t>4,793.7</a:t>
                       </a:r>
                       <a:endParaRPr lang="en-US" sz="1250" dirty="0">
                         <a:latin typeface="Calibri" charset="0"/>
@@ -41611,7 +41659,7 @@
                           <a:ea typeface="Calibri" pitchFamily="34" charset="-122"/>
                           <a:cs typeface="Calibri" pitchFamily="34" charset="-120"/>
                         </a:rPr>
-                        <a:t>5 203,6</a:t>
+                        <a:t>5,203.6</a:t>
                       </a:r>
                       <a:endParaRPr lang="en-US" sz="1250" dirty="0">
                         <a:latin typeface="Calibri" charset="0"/>
@@ -41663,7 +41711,7 @@
                           <a:ea typeface="Calibri" pitchFamily="34" charset="-122"/>
                           <a:cs typeface="Calibri" pitchFamily="34" charset="-120"/>
                         </a:rPr>
-                        <a:t>4 800,0</a:t>
+                        <a:t>4,800.0</a:t>
                       </a:r>
                       <a:endParaRPr lang="en-US" sz="1250" dirty="0">
                         <a:latin typeface="Calibri" charset="0"/>
@@ -41757,7 +41805,7 @@
                           <a:ea typeface="Calibri" pitchFamily="34" charset="-122"/>
                           <a:cs typeface="Calibri" pitchFamily="34" charset="-120"/>
                         </a:rPr>
-                        <a:t>4 795,4</a:t>
+                        <a:t>4,795.4</a:t>
                       </a:r>
                       <a:endParaRPr lang="en-US" sz="1250" dirty="0">
                         <a:latin typeface="Calibri" charset="0"/>
@@ -41804,7 +41852,7 @@
                           <a:ea typeface="Calibri" pitchFamily="34" charset="-122"/>
                           <a:cs typeface="Calibri" pitchFamily="34" charset="-120"/>
                         </a:rPr>
-                        <a:t>4 793,7</a:t>
+                        <a:t>4,793.7</a:t>
                       </a:r>
                       <a:endParaRPr lang="en-US" sz="1250" dirty="0">
                         <a:latin typeface="Calibri" charset="0"/>
@@ -41872,7 +41920,7 @@
                 <a:ea typeface="Calibri" pitchFamily="34" charset="-122"/>
                 <a:cs typeface="Calibri" pitchFamily="34" charset="-120"/>
               </a:rPr>
-              <a:t>Hipervolum ×1 000, më i miri nga 3 seed-a, 1 200 s secili. Me të trasha: fituesi i rreshtit. — asnjë pikë e lejuar në asnjë seed.</a:t>
+              <a:t>Hipervolum ×1,000, më i miri nga 3 seed-a, 1,200 s secili. Me të trasha: fituesi i rreshtit. — asnjë pikë e lejuar në asnjë seed.</a:t>
             </a:r>
             <a:endParaRPr lang="en-US" sz="1050" dirty="0"/>
           </a:p>
@@ -41936,7 +41984,7 @@
                 <a:ea typeface="Calibri" pitchFamily="34" charset="-122"/>
                 <a:cs typeface="Calibri" pitchFamily="34" charset="-120"/>
               </a:rPr>
-              <a:t>1 200 s për ekzekutim, tre seed-a; një bërthamë CPU secili, Spacekangaroos në një GPU T4; çdo përgjigje rivlerësohet nga një vlerësues i kontrolluar me kodin e ESA-s.</a:t>
+              <a:t>1,200 s për ekzekutim, tre seed-a; një bërthamë CPU secili, Spacekangaroos në një GPU T4; çdo përgjigje rivlerësohet nga një vlerësues i kontrolluar me kodin e ESA-s.</a:t>
             </a:r>
             <a:endParaRPr lang="en-US" sz="1350" dirty="0"/>
           </a:p>
@@ -44028,7 +44076,7 @@
                 <a:ea typeface="Calibri" pitchFamily="34" charset="-122"/>
                 <a:cs typeface="Calibri" pitchFamily="34" charset="-120"/>
               </a:rPr>
-              <a:t>275 225 HV diferencë</a:t>
+              <a:t>275,225 HV diferencë</a:t>
             </a:r>
             <a:endParaRPr lang="en-US" sz="1150" dirty="0"/>
           </a:p>
@@ -44194,7 +44242,7 @@
                 <a:ea typeface="Calibri" pitchFamily="34" charset="-122"/>
                 <a:cs typeface="Calibri" pitchFamily="34" charset="-120"/>
               </a:rPr>
-              <a:t>1 234 HV diferencë</a:t>
+              <a:t>1,234 HV diferencë</a:t>
             </a:r>
             <a:endParaRPr lang="en-US" sz="1150" dirty="0"/>
           </a:p>
@@ -44233,7 +44281,7 @@
                 <a:ea typeface="Calibri" pitchFamily="34" charset="-122"/>
                 <a:cs typeface="Calibri" pitchFamily="34" charset="-120"/>
               </a:rPr>
-              <a:t>1,50M HV</a:t>
+              <a:t>1.50M HV</a:t>
             </a:r>
             <a:endParaRPr lang="en-US" sz="1000" dirty="0"/>
           </a:p>
@@ -44272,7 +44320,7 @@
                 <a:ea typeface="Calibri" pitchFamily="34" charset="-122"/>
                 <a:cs typeface="Calibri" pitchFamily="34" charset="-120"/>
               </a:rPr>
-              <a:t>1,83M HV</a:t>
+              <a:t>1.83M HV</a:t>
             </a:r>
             <a:endParaRPr lang="en-US" sz="1000" dirty="0"/>
           </a:p>
@@ -46644,7 +46692,7 @@
                 <a:ea typeface="Calibri" pitchFamily="34" charset="-122"/>
                 <a:cs typeface="Calibri" pitchFamily="34" charset="-120"/>
               </a:rPr>
-              <a:t>e vëzhguar: 21 519 HV</a:t>
+              <a:t>e vëzhguar: 21,519 HV</a:t>
             </a:r>
             <a:endParaRPr lang="en-US" sz="1200" dirty="0"/>
           </a:p>
@@ -46683,7 +46731,7 @@
                 <a:ea typeface="Calibri" pitchFamily="34" charset="-122"/>
                 <a:cs typeface="Calibri" pitchFamily="34" charset="-120"/>
               </a:rPr>
-              <a:t>vetëm 4,6% e 100 000 rishpërndarjeve e lëvizin totalin kaq larg</a:t>
+              <a:t>vetëm 4.6% e 100,000 rishpërndarjeve e lëvizin totalin kaq larg</a:t>
             </a:r>
             <a:endParaRPr lang="en-US" sz="1100" dirty="0"/>
           </a:p>
@@ -46761,7 +46809,7 @@
                 <a:ea typeface="Century Schoolbook" pitchFamily="34" charset="-122"/>
                 <a:cs typeface="Century Schoolbook" pitchFamily="34" charset="-120"/>
               </a:rPr>
-              <a:t>Zhurma varet nga metoda dhe instanca (9 deri në 281 976 HV për tre seed-a): asnjë prag i vetëm s’gjykon dot çdo rresht.</a:t>
+              <a:t>Zhurma varet nga metoda dhe instanca (9 deri në 281,976 HV për tre seed-a): asnjë prag i vetëm s’gjykon dot çdo rresht.</a:t>
             </a:r>
             <a:endParaRPr lang="en-US" sz="1350" dirty="0"/>
           </a:p>

</xml_diff>